<commit_message>
Polish keynote deck: fix spacing, contrast, and knowledge-graph image after visual QA
</commit_message>
<xml_diff>
--- a/slides/Transformative_Science_Feng_Keynote.pptx
+++ b/slides/Transformative_Science_Feng_Keynote.pptx
@@ -5436,7 +5436,7 @@
         <p:spPr>
           <a:xfrm>
             <a:off x="777240" y="2258568"/>
-            <a:ext cx="4663440" cy="1207008"/>
+            <a:ext cx="4663440" cy="1097280"/>
           </a:xfrm>
           <a:prstGeom prst="rect">
             <a:avLst/>
@@ -5474,8 +5474,8 @@
         </p:nvSpPr>
         <p:spPr>
           <a:xfrm>
-            <a:off x="777240" y="3421685"/>
-            <a:ext cx="4663440" cy="833933"/>
+            <a:off x="777240" y="3553358"/>
+            <a:ext cx="4663440" cy="702259"/>
           </a:xfrm>
           <a:prstGeom prst="rect">
             <a:avLst/>
@@ -5562,7 +5562,7 @@
         <p:spPr>
           <a:xfrm>
             <a:off x="6263640" y="2258568"/>
-            <a:ext cx="5120640" cy="1207008"/>
+            <a:ext cx="5120640" cy="1097280"/>
           </a:xfrm>
           <a:prstGeom prst="rect">
             <a:avLst/>
@@ -5600,8 +5600,8 @@
         </p:nvSpPr>
         <p:spPr>
           <a:xfrm>
-            <a:off x="6263640" y="3421685"/>
-            <a:ext cx="5120640" cy="833933"/>
+            <a:off x="6263640" y="3553358"/>
+            <a:ext cx="5120640" cy="702259"/>
           </a:xfrm>
           <a:prstGeom prst="rect">
             <a:avLst/>
@@ -7338,7 +7338,7 @@
         <p:spPr>
           <a:xfrm>
             <a:off x="777240" y="2212848"/>
-            <a:ext cx="4663440" cy="1307592"/>
+            <a:ext cx="4663440" cy="1188720"/>
           </a:xfrm>
           <a:prstGeom prst="rect">
             <a:avLst/>
@@ -7376,8 +7376,8 @@
         </p:nvSpPr>
         <p:spPr>
           <a:xfrm>
-            <a:off x="777240" y="3482035"/>
-            <a:ext cx="4663440" cy="903427"/>
+            <a:off x="777240" y="3624682"/>
+            <a:ext cx="4663440" cy="760781"/>
           </a:xfrm>
           <a:prstGeom prst="rect">
             <a:avLst/>
@@ -7464,7 +7464,7 @@
         <p:spPr>
           <a:xfrm>
             <a:off x="6263640" y="2212848"/>
-            <a:ext cx="5120640" cy="1307592"/>
+            <a:ext cx="5120640" cy="1188720"/>
           </a:xfrm>
           <a:prstGeom prst="rect">
             <a:avLst/>
@@ -7482,7 +7482,7 @@
             <a:r>
               <a:rPr lang="en-US" sz="3200" b="1" dirty="0">
                 <a:solidFill>
-                  <a:srgbClr val="6B6860"/>
+                  <a:srgbClr val="5C5750"/>
                 </a:solidFill>
                 <a:latin typeface="Georgia" pitchFamily="34" charset="0"/>
                 <a:ea typeface="Georgia" pitchFamily="34" charset="-122"/>
@@ -7502,8 +7502,8 @@
         </p:nvSpPr>
         <p:spPr>
           <a:xfrm>
-            <a:off x="6263640" y="3482035"/>
-            <a:ext cx="5120640" cy="903427"/>
+            <a:off x="6263640" y="3624682"/>
+            <a:ext cx="5120640" cy="760781"/>
           </a:xfrm>
           <a:prstGeom prst="rect">
             <a:avLst/>
@@ -11293,16 +11293,16 @@
         <p:spPr>
           <a:xfrm>
             <a:off x="822960" y="2194560"/>
-            <a:ext cx="4572000" cy="2468880"/>
-          </a:xfrm>
-          <a:prstGeom prst="rect">
-            <a:avLst/>
-          </a:prstGeom>
-          <a:noFill/>
-          <a:ln/>
-        </p:spPr>
-        <p:txBody>
-          <a:bodyPr wrap="square" lIns="0" tIns="0" rIns="0" bIns="0" rtlCol="0" anchor="ctr"/>
+            <a:ext cx="4572000" cy="2377440"/>
+          </a:xfrm>
+          <a:prstGeom prst="rect">
+            <a:avLst/>
+          </a:prstGeom>
+          <a:noFill/>
+          <a:ln/>
+        </p:spPr>
+        <p:txBody>
+          <a:bodyPr wrap="square" lIns="0" tIns="0" rIns="0" bIns="0" rtlCol="0" anchor="t"/>
           <a:lstStyle/>
           <a:p>
             <a:pPr indent="0" marL="0">
@@ -11399,16 +11399,16 @@
         <p:spPr>
           <a:xfrm>
             <a:off x="6126480" y="2194560"/>
-            <a:ext cx="4572000" cy="2468880"/>
-          </a:xfrm>
-          <a:prstGeom prst="rect">
-            <a:avLst/>
-          </a:prstGeom>
-          <a:noFill/>
-          <a:ln/>
-        </p:spPr>
-        <p:txBody>
-          <a:bodyPr wrap="square" lIns="0" tIns="0" rIns="0" bIns="0" rtlCol="0" anchor="ctr"/>
+            <a:ext cx="4572000" cy="2377440"/>
+          </a:xfrm>
+          <a:prstGeom prst="rect">
+            <a:avLst/>
+          </a:prstGeom>
+          <a:noFill/>
+          <a:ln/>
+        </p:spPr>
+        <p:txBody>
+          <a:bodyPr wrap="square" lIns="0" tIns="0" rIns="0" bIns="0" rtlCol="0" anchor="t"/>
           <a:lstStyle/>
           <a:p>
             <a:pPr indent="0" marL="0">
@@ -15259,23 +15259,23 @@
         <p:spPr>
           <a:xfrm>
             <a:off x="6629400" y="1901952"/>
-            <a:ext cx="1828800" cy="694944"/>
-          </a:xfrm>
-          <a:prstGeom prst="rect">
-            <a:avLst/>
-          </a:prstGeom>
-          <a:noFill/>
-          <a:ln/>
-        </p:spPr>
-        <p:txBody>
-          <a:bodyPr wrap="square" lIns="0" tIns="0" rIns="0" bIns="0" rtlCol="0" anchor="ctr"/>
-          <a:lstStyle/>
-          <a:p>
-            <a:pPr indent="0" marL="0">
-              <a:buNone/>
-            </a:pPr>
-            <a:r>
-              <a:rPr lang="en-US" sz="2400" b="1" dirty="0">
+            <a:ext cx="1737360" cy="694944"/>
+          </a:xfrm>
+          <a:prstGeom prst="rect">
+            <a:avLst/>
+          </a:prstGeom>
+          <a:noFill/>
+          <a:ln/>
+        </p:spPr>
+        <p:txBody>
+          <a:bodyPr wrap="square" lIns="0" tIns="0" rIns="0" bIns="0" rtlCol="0" anchor="ctr"/>
+          <a:lstStyle/>
+          <a:p>
+            <a:pPr indent="0" marL="0">
+              <a:buNone/>
+            </a:pPr>
+            <a:r>
+              <a:rPr lang="en-US" sz="2200" b="1" dirty="0">
                 <a:solidFill>
                   <a:srgbClr val="A3690C"/>
                 </a:solidFill>
@@ -15285,7 +15285,7 @@
               </a:rPr>
               <a:t>500+</a:t>
             </a:r>
-            <a:endParaRPr lang="en-US" sz="2400" dirty="0"/>
+            <a:endParaRPr lang="en-US" sz="2200" dirty="0"/>
           </a:p>
         </p:txBody>
       </p:sp>
@@ -15297,24 +15297,27 @@
         </p:nvSpPr>
         <p:spPr>
           <a:xfrm>
-            <a:off x="8412480" y="1901952"/>
-            <a:ext cx="2926080" cy="694944"/>
-          </a:xfrm>
-          <a:prstGeom prst="rect">
-            <a:avLst/>
-          </a:prstGeom>
-          <a:noFill/>
-          <a:ln/>
-        </p:spPr>
-        <p:txBody>
-          <a:bodyPr wrap="square" lIns="0" tIns="0" rIns="0" bIns="0" rtlCol="0" anchor="ctr"/>
-          <a:lstStyle/>
-          <a:p>
-            <a:pPr indent="0" marL="0">
-              <a:buNone/>
-            </a:pPr>
-            <a:r>
-              <a:rPr lang="en-US" sz="1200" dirty="0">
+            <a:off x="8321040" y="1901952"/>
+            <a:ext cx="3063240" cy="694944"/>
+          </a:xfrm>
+          <a:prstGeom prst="rect">
+            <a:avLst/>
+          </a:prstGeom>
+          <a:noFill/>
+          <a:ln/>
+        </p:spPr>
+        <p:txBody>
+          <a:bodyPr wrap="square" lIns="0" tIns="0" rIns="0" bIns="0" rtlCol="0" anchor="ctr"/>
+          <a:lstStyle/>
+          <a:p>
+            <a:pPr indent="0" marL="0">
+              <a:lnSpc>
+                <a:spcPts val="1400"/>
+              </a:lnSpc>
+              <a:buNone/>
+            </a:pPr>
+            <a:r>
+              <a:rPr lang="en-US" sz="1150" dirty="0">
                 <a:solidFill>
                   <a:srgbClr val="201D18"/>
                 </a:solidFill>
@@ -15324,7 +15327,7 @@
               </a:rPr>
               <a:t>peer-reviewed publications</a:t>
             </a:r>
-            <a:endParaRPr lang="en-US" sz="1200" dirty="0"/>
+            <a:endParaRPr lang="en-US" sz="1150" dirty="0"/>
           </a:p>
         </p:txBody>
       </p:sp>
@@ -15362,23 +15365,23 @@
         <p:spPr>
           <a:xfrm>
             <a:off x="6629400" y="2889504"/>
-            <a:ext cx="1828800" cy="694944"/>
-          </a:xfrm>
-          <a:prstGeom prst="rect">
-            <a:avLst/>
-          </a:prstGeom>
-          <a:noFill/>
-          <a:ln/>
-        </p:spPr>
-        <p:txBody>
-          <a:bodyPr wrap="square" lIns="0" tIns="0" rIns="0" bIns="0" rtlCol="0" anchor="ctr"/>
-          <a:lstStyle/>
-          <a:p>
-            <a:pPr indent="0" marL="0">
-              <a:buNone/>
-            </a:pPr>
-            <a:r>
-              <a:rPr lang="en-US" sz="2400" b="1" dirty="0">
+            <a:ext cx="1737360" cy="694944"/>
+          </a:xfrm>
+          <a:prstGeom prst="rect">
+            <a:avLst/>
+          </a:prstGeom>
+          <a:noFill/>
+          <a:ln/>
+        </p:spPr>
+        <p:txBody>
+          <a:bodyPr wrap="square" lIns="0" tIns="0" rIns="0" bIns="0" rtlCol="0" anchor="ctr"/>
+          <a:lstStyle/>
+          <a:p>
+            <a:pPr indent="0" marL="0">
+              <a:buNone/>
+            </a:pPr>
+            <a:r>
+              <a:rPr lang="en-US" sz="2200" b="1" dirty="0">
                 <a:solidFill>
                   <a:srgbClr val="A3690C"/>
                 </a:solidFill>
@@ -15388,7 +15391,7 @@
               </a:rPr>
               <a:t>3,219</a:t>
             </a:r>
-            <a:endParaRPr lang="en-US" sz="2400" dirty="0"/>
+            <a:endParaRPr lang="en-US" sz="2200" dirty="0"/>
           </a:p>
         </p:txBody>
       </p:sp>
@@ -15400,24 +15403,27 @@
         </p:nvSpPr>
         <p:spPr>
           <a:xfrm>
-            <a:off x="8412480" y="2889504"/>
-            <a:ext cx="2926080" cy="694944"/>
-          </a:xfrm>
-          <a:prstGeom prst="rect">
-            <a:avLst/>
-          </a:prstGeom>
-          <a:noFill/>
-          <a:ln/>
-        </p:spPr>
-        <p:txBody>
-          <a:bodyPr wrap="square" lIns="0" tIns="0" rIns="0" bIns="0" rtlCol="0" anchor="ctr"/>
-          <a:lstStyle/>
-          <a:p>
-            <a:pPr indent="0" marL="0">
-              <a:buNone/>
-            </a:pPr>
-            <a:r>
-              <a:rPr lang="en-US" sz="1200" dirty="0">
+            <a:off x="8321040" y="2889504"/>
+            <a:ext cx="3063240" cy="694944"/>
+          </a:xfrm>
+          <a:prstGeom prst="rect">
+            <a:avLst/>
+          </a:prstGeom>
+          <a:noFill/>
+          <a:ln/>
+        </p:spPr>
+        <p:txBody>
+          <a:bodyPr wrap="square" lIns="0" tIns="0" rIns="0" bIns="0" rtlCol="0" anchor="ctr"/>
+          <a:lstStyle/>
+          <a:p>
+            <a:pPr indent="0" marL="0">
+              <a:lnSpc>
+                <a:spcPts val="1400"/>
+              </a:lnSpc>
+              <a:buNone/>
+            </a:pPr>
+            <a:r>
+              <a:rPr lang="en-US" sz="1150" dirty="0">
                 <a:solidFill>
                   <a:srgbClr val="201D18"/>
                 </a:solidFill>
@@ -15427,7 +15433,7 @@
               </a:rPr>
               <a:t>distinct co-authors on record</a:t>
             </a:r>
-            <a:endParaRPr lang="en-US" sz="1200" dirty="0"/>
+            <a:endParaRPr lang="en-US" sz="1150" dirty="0"/>
           </a:p>
         </p:txBody>
       </p:sp>
@@ -15465,23 +15471,23 @@
         <p:spPr>
           <a:xfrm>
             <a:off x="6629400" y="3877056"/>
-            <a:ext cx="1828800" cy="694944"/>
-          </a:xfrm>
-          <a:prstGeom prst="rect">
-            <a:avLst/>
-          </a:prstGeom>
-          <a:noFill/>
-          <a:ln/>
-        </p:spPr>
-        <p:txBody>
-          <a:bodyPr wrap="square" lIns="0" tIns="0" rIns="0" bIns="0" rtlCol="0" anchor="ctr"/>
-          <a:lstStyle/>
-          <a:p>
-            <a:pPr indent="0" marL="0">
-              <a:buNone/>
-            </a:pPr>
-            <a:r>
-              <a:rPr lang="en-US" sz="2400" b="1" dirty="0">
+            <a:ext cx="1737360" cy="694944"/>
+          </a:xfrm>
+          <a:prstGeom prst="rect">
+            <a:avLst/>
+          </a:prstGeom>
+          <a:noFill/>
+          <a:ln/>
+        </p:spPr>
+        <p:txBody>
+          <a:bodyPr wrap="square" lIns="0" tIns="0" rIns="0" bIns="0" rtlCol="0" anchor="ctr"/>
+          <a:lstStyle/>
+          <a:p>
+            <a:pPr indent="0" marL="0">
+              <a:buNone/>
+            </a:pPr>
+            <a:r>
+              <a:rPr lang="en-US" sz="2200" b="1" dirty="0">
                 <a:solidFill>
                   <a:srgbClr val="A3690C"/>
                 </a:solidFill>
@@ -15491,7 +15497,7 @@
               </a:rPr>
               <a:t>2018–2024</a:t>
             </a:r>
-            <a:endParaRPr lang="en-US" sz="2400" dirty="0"/>
+            <a:endParaRPr lang="en-US" sz="2200" dirty="0"/>
           </a:p>
         </p:txBody>
       </p:sp>
@@ -15503,24 +15509,27 @@
         </p:nvSpPr>
         <p:spPr>
           <a:xfrm>
-            <a:off x="8412480" y="3877056"/>
-            <a:ext cx="2926080" cy="694944"/>
-          </a:xfrm>
-          <a:prstGeom prst="rect">
-            <a:avLst/>
-          </a:prstGeom>
-          <a:noFill/>
-          <a:ln/>
-        </p:spPr>
-        <p:txBody>
-          <a:bodyPr wrap="square" lIns="0" tIns="0" rIns="0" bIns="0" rtlCol="0" anchor="ctr"/>
-          <a:lstStyle/>
-          <a:p>
-            <a:pPr indent="0" marL="0">
-              <a:buNone/>
-            </a:pPr>
-            <a:r>
-              <a:rPr lang="en-US" sz="1200" dirty="0">
+            <a:off x="8321040" y="3877056"/>
+            <a:ext cx="3063240" cy="694944"/>
+          </a:xfrm>
+          <a:prstGeom prst="rect">
+            <a:avLst/>
+          </a:prstGeom>
+          <a:noFill/>
+          <a:ln/>
+        </p:spPr>
+        <p:txBody>
+          <a:bodyPr wrap="square" lIns="0" tIns="0" rIns="0" bIns="0" rtlCol="0" anchor="ctr"/>
+          <a:lstStyle/>
+          <a:p>
+            <a:pPr indent="0" marL="0">
+              <a:lnSpc>
+                <a:spcPts val="1400"/>
+              </a:lnSpc>
+              <a:buNone/>
+            </a:pPr>
+            <a:r>
+              <a:rPr lang="en-US" sz="1150" dirty="0">
                 <a:solidFill>
                   <a:srgbClr val="201D18"/>
                 </a:solidFill>
@@ -15530,7 +15539,7 @@
               </a:rPr>
               <a:t>Chair, NRG Oncology GU Cancer Committee</a:t>
             </a:r>
-            <a:endParaRPr lang="en-US" sz="1200" dirty="0"/>
+            <a:endParaRPr lang="en-US" sz="1150" dirty="0"/>
           </a:p>
         </p:txBody>
       </p:sp>
@@ -15568,23 +15577,23 @@
         <p:spPr>
           <a:xfrm>
             <a:off x="6629400" y="4864608"/>
-            <a:ext cx="1828800" cy="694944"/>
-          </a:xfrm>
-          <a:prstGeom prst="rect">
-            <a:avLst/>
-          </a:prstGeom>
-          <a:noFill/>
-          <a:ln/>
-        </p:spPr>
-        <p:txBody>
-          <a:bodyPr wrap="square" lIns="0" tIns="0" rIns="0" bIns="0" rtlCol="0" anchor="ctr"/>
-          <a:lstStyle/>
-          <a:p>
-            <a:pPr indent="0" marL="0">
-              <a:buNone/>
-            </a:pPr>
-            <a:r>
-              <a:rPr lang="en-US" sz="2400" b="1" dirty="0">
+            <a:ext cx="1737360" cy="694944"/>
+          </a:xfrm>
+          <a:prstGeom prst="rect">
+            <a:avLst/>
+          </a:prstGeom>
+          <a:noFill/>
+          <a:ln/>
+        </p:spPr>
+        <p:txBody>
+          <a:bodyPr wrap="square" lIns="0" tIns="0" rIns="0" bIns="0" rtlCol="0" anchor="ctr"/>
+          <a:lstStyle/>
+          <a:p>
+            <a:pPr indent="0" marL="0">
+              <a:buNone/>
+            </a:pPr>
+            <a:r>
+              <a:rPr lang="en-US" sz="2200" b="1" dirty="0">
                 <a:solidFill>
                   <a:srgbClr val="A3690C"/>
                 </a:solidFill>
@@ -15594,7 +15603,7 @@
               </a:rPr>
               <a:t>2019–2024</a:t>
             </a:r>
-            <a:endParaRPr lang="en-US" sz="2400" dirty="0"/>
+            <a:endParaRPr lang="en-US" sz="2200" dirty="0"/>
           </a:p>
         </p:txBody>
       </p:sp>
@@ -15606,24 +15615,27 @@
         </p:nvSpPr>
         <p:spPr>
           <a:xfrm>
-            <a:off x="8412480" y="4864608"/>
-            <a:ext cx="2926080" cy="694944"/>
-          </a:xfrm>
-          <a:prstGeom prst="rect">
-            <a:avLst/>
-          </a:prstGeom>
-          <a:noFill/>
-          <a:ln/>
-        </p:spPr>
-        <p:txBody>
-          <a:bodyPr wrap="square" lIns="0" tIns="0" rIns="0" bIns="0" rtlCol="0" anchor="ctr"/>
-          <a:lstStyle/>
-          <a:p>
-            <a:pPr indent="0" marL="0">
-              <a:buNone/>
-            </a:pPr>
-            <a:r>
-              <a:rPr lang="en-US" sz="1200" dirty="0">
+            <a:off x="8321040" y="4864608"/>
+            <a:ext cx="3063240" cy="694944"/>
+          </a:xfrm>
+          <a:prstGeom prst="rect">
+            <a:avLst/>
+          </a:prstGeom>
+          <a:noFill/>
+          <a:ln/>
+        </p:spPr>
+        <p:txBody>
+          <a:bodyPr wrap="square" lIns="0" tIns="0" rIns="0" bIns="0" rtlCol="0" anchor="ctr"/>
+          <a:lstStyle/>
+          <a:p>
+            <a:pPr indent="0" marL="0">
+              <a:lnSpc>
+                <a:spcPts val="1400"/>
+              </a:lnSpc>
+              <a:buNone/>
+            </a:pPr>
+            <a:r>
+              <a:rPr lang="en-US" sz="1150" dirty="0">
                 <a:solidFill>
                   <a:srgbClr val="201D18"/>
                 </a:solidFill>
@@ -15631,9 +15643,9 @@
                 <a:ea typeface="Calibri" pitchFamily="34" charset="-122"/>
                 <a:cs typeface="Calibri" pitchFamily="34" charset="-120"/>
               </a:rPr>
-              <a:t>Founding Director, UCSF Benioff Initiative for Prostate Cancer Research</a:t>
-            </a:r>
-            <a:endParaRPr lang="en-US" sz="1200" dirty="0"/>
+              <a:t>Founding Director, Benioff Initiative for Prostate Cancer</a:t>
+            </a:r>
+            <a:endParaRPr lang="en-US" sz="1150" dirty="0"/>
           </a:p>
         </p:txBody>
       </p:sp>
@@ -16552,7 +16564,7 @@
                 <a:ea typeface="Calibri" pitchFamily="34" charset="-122"/>
                 <a:cs typeface="Calibri" pitchFamily="34" charset="-120"/>
               </a:rPr>
-              <a:t>An unannotated, prostate-restricted long non-coding RNA found by sequencing the transcriptome across 100+ tumors. Later shown to repress BRCA2 and drive MYC expression through their 3′ UTRs.</a:t>
+              <a:t>An unannotated, prostate-restricted long non-coding RNA found by sequencing the transcriptome across 100+ tumors. Later shown to repress BRCA2 and drive MYC expression through their 3'-untranslated regions.</a:t>
             </a:r>
             <a:endParaRPr lang="en-US" sz="1400" dirty="0"/>
           </a:p>
@@ -16981,7 +16993,7 @@
         <p:spPr>
           <a:xfrm>
             <a:off x="777240" y="2212848"/>
-            <a:ext cx="2834640" cy="1056132"/>
+            <a:ext cx="2834640" cy="960120"/>
           </a:xfrm>
           <a:prstGeom prst="rect">
             <a:avLst/>
@@ -17019,8 +17031,8 @@
         </p:nvSpPr>
         <p:spPr>
           <a:xfrm>
-            <a:off x="777240" y="3216859"/>
-            <a:ext cx="2834640" cy="729691"/>
+            <a:off x="777240" y="3332074"/>
+            <a:ext cx="2834640" cy="614477"/>
           </a:xfrm>
           <a:prstGeom prst="rect">
             <a:avLst/>
@@ -17107,7 +17119,7 @@
         <p:spPr>
           <a:xfrm>
             <a:off x="4251960" y="2212848"/>
-            <a:ext cx="2834640" cy="1056132"/>
+            <a:ext cx="2834640" cy="960120"/>
           </a:xfrm>
           <a:prstGeom prst="rect">
             <a:avLst/>
@@ -17145,8 +17157,8 @@
         </p:nvSpPr>
         <p:spPr>
           <a:xfrm>
-            <a:off x="4251960" y="3216859"/>
-            <a:ext cx="2834640" cy="729691"/>
+            <a:off x="4251960" y="3332074"/>
+            <a:ext cx="2834640" cy="614477"/>
           </a:xfrm>
           <a:prstGeom prst="rect">
             <a:avLst/>
@@ -17253,7 +17265,7 @@
         <p:spPr>
           <a:xfrm>
             <a:off x="7726680" y="2212848"/>
-            <a:ext cx="3657600" cy="1056132"/>
+            <a:ext cx="3657600" cy="960120"/>
           </a:xfrm>
           <a:prstGeom prst="rect">
             <a:avLst/>
@@ -17269,7 +17281,7 @@
               <a:buNone/>
             </a:pPr>
             <a:r>
-              <a:rPr lang="en-US" sz="3000" b="1" dirty="0">
+              <a:rPr lang="en-US" sz="2400" b="1" dirty="0">
                 <a:solidFill>
                   <a:srgbClr val="A3690C"/>
                 </a:solidFill>
@@ -17279,7 +17291,7 @@
               </a:rPr>
               <a:t>Independent</a:t>
             </a:r>
-            <a:endParaRPr lang="en-US" sz="3000" dirty="0"/>
+            <a:endParaRPr lang="en-US" sz="2400" dirty="0"/>
           </a:p>
         </p:txBody>
       </p:sp>
@@ -17291,8 +17303,8 @@
         </p:nvSpPr>
         <p:spPr>
           <a:xfrm>
-            <a:off x="7726680" y="3216859"/>
-            <a:ext cx="3657600" cy="729691"/>
+            <a:off x="7726680" y="3332074"/>
+            <a:ext cx="3657600" cy="614477"/>
           </a:xfrm>
           <a:prstGeom prst="rect">
             <a:avLst/>
@@ -17339,27 +17351,7 @@
                 <a:ea typeface="Calibri" pitchFamily="34" charset="-122"/>
                 <a:cs typeface="Calibri" pitchFamily="34" charset="-120"/>
               </a:rPr>
-              <a:t>the first RNA biomarker of its kind</a:t>
-            </a:r>
-            <a:endParaRPr lang="en-US" sz="1150" dirty="0"/>
-          </a:p>
-          <a:p>
-            <a:pPr algn="l" indent="0" marL="0">
-              <a:lnSpc>
-                <a:spcPts val="1400"/>
-              </a:lnSpc>
-              <a:buNone/>
-            </a:pPr>
-            <a:r>
-              <a:rPr lang="en-US" sz="1150" dirty="0">
-                <a:solidFill>
-                  <a:srgbClr val="6B6860"/>
-                </a:solidFill>
-                <a:latin typeface="Calibri" pitchFamily="34" charset="0"/>
-                <a:ea typeface="Calibri" pitchFamily="34" charset="-122"/>
-                <a:cs typeface="Calibri" pitchFamily="34" charset="-120"/>
-              </a:rPr>
-              <a:t>validated across institutions</a:t>
+              <a:t>first RNA biomarker validated across institutions</a:t>
             </a:r>
             <a:endParaRPr lang="en-US" sz="1150" dirty="0"/>
           </a:p>

</xml_diff>

<commit_message>
Correct symposium ordinal: 3rd annual to 4th annual, across website, deck, and research notes
</commit_message>
<xml_diff>
--- a/slides/Transformative_Science_Feng_Keynote.pptx
+++ b/slides/Transformative_Science_Feng_Keynote.pptx
@@ -3845,7 +3845,7 @@
                 <a:ea typeface="Calibri" pitchFamily="34" charset="-122"/>
                 <a:cs typeface="Calibri" pitchFamily="34" charset="-120"/>
               </a:rPr>
-              <a:t>3RD ANNUAL FENG SYMPOSIUM ON PROSTATE CANCER REVOLUTIONS</a:t>
+              <a:t>4TH ANNUAL FENG SYMPOSIUM ON PROSTATE CANCER REVOLUTIONS</a:t>
             </a:r>
             <a:endParaRPr lang="en-US" sz="1400" dirty="0"/>
           </a:p>
@@ -11768,7 +11768,7 @@
                 <a:ea typeface="Calibri" pitchFamily="34" charset="-122"/>
                 <a:cs typeface="Calibri" pitchFamily="34" charset="-120"/>
               </a:rPr>
-              <a:t>Now in its third year, timed to precede the ASCO GU Cancers Symposium</a:t>
+              <a:t>Now in its fourth year, timed to precede the ASCO GU Cancers Symposium</a:t>
             </a:r>
             <a:endParaRPr lang="en-US" sz="1650" dirty="0"/>
           </a:p>

</xml_diff>

<commit_message>
Re-theme keynote deck with official Johns Hopkins brand colors (Heritage Blue / Spirit Blue / Gold)
</commit_message>
<xml_diff>
--- a/slides/Transformative_Science_Feng_Keynote.pptx
+++ b/slides/Transformative_Science_Feng_Keynote.pptx
@@ -3794,7 +3794,7 @@
     <p:bg>
       <p:bgPr>
         <a:solidFill>
-          <a:srgbClr val="12161A"/>
+          <a:srgbClr val="68ACE5"/>
         </a:solidFill>
       </p:bgPr>
     </p:bg>
@@ -3839,7 +3839,7 @@
             <a:r>
               <a:rPr lang="en-US" sz="1400" b="1" spc="150" kern="0" dirty="0">
                 <a:solidFill>
-                  <a:srgbClr val="A3690C"/>
+                  <a:srgbClr val="002D72"/>
                 </a:solidFill>
                 <a:latin typeface="Calibri" pitchFamily="34" charset="0"/>
                 <a:ea typeface="Calibri" pitchFamily="34" charset="-122"/>
@@ -3881,7 +3881,7 @@
             <a:r>
               <a:rPr lang="en-US" sz="4000" b="1" dirty="0">
                 <a:solidFill>
-                  <a:srgbClr val="E8E4DB"/>
+                  <a:srgbClr val="002D72"/>
                 </a:solidFill>
                 <a:latin typeface="Georgia" pitchFamily="34" charset="0"/>
                 <a:ea typeface="Georgia" pitchFamily="34" charset="-122"/>
@@ -3901,7 +3901,7 @@
             <a:r>
               <a:rPr lang="en-US" sz="4000" b="1" dirty="0">
                 <a:solidFill>
-                  <a:srgbClr val="E8E4DB"/>
+                  <a:srgbClr val="002D72"/>
                 </a:solidFill>
                 <a:latin typeface="Georgia" pitchFamily="34" charset="0"/>
                 <a:ea typeface="Georgia" pitchFamily="34" charset="-122"/>
@@ -3940,7 +3940,7 @@
             <a:r>
               <a:rPr lang="en-US" sz="1800" i="1" dirty="0">
                 <a:solidFill>
-                  <a:srgbClr val="9B968C"/>
+                  <a:srgbClr val="002D72"/>
                 </a:solidFill>
                 <a:latin typeface="Calibri" pitchFamily="34" charset="0"/>
                 <a:ea typeface="Calibri" pitchFamily="34" charset="-122"/>
@@ -3969,7 +3969,7 @@
           <a:noFill/>
           <a:ln w="25400">
             <a:solidFill>
-              <a:srgbClr val="A3690C"/>
+              <a:srgbClr val="F1C400"/>
             </a:solidFill>
             <a:prstDash val="solid"/>
           </a:ln>
@@ -4002,7 +4002,7 @@
             <a:r>
               <a:rPr lang="en-US" sz="1600" b="1" dirty="0">
                 <a:solidFill>
-                  <a:srgbClr val="E8E4DB"/>
+                  <a:srgbClr val="002D72"/>
                 </a:solidFill>
                 <a:latin typeface="Calibri" pitchFamily="34" charset="0"/>
                 <a:ea typeface="Calibri" pitchFamily="34" charset="-122"/>
@@ -4044,7 +4044,7 @@
             <a:r>
               <a:rPr lang="en-US" sz="1200" dirty="0">
                 <a:solidFill>
-                  <a:srgbClr val="9B968C"/>
+                  <a:srgbClr val="002D72"/>
                 </a:solidFill>
                 <a:latin typeface="Calibri" pitchFamily="34" charset="0"/>
                 <a:ea typeface="Calibri" pitchFamily="34" charset="-122"/>
@@ -4064,7 +4064,7 @@
             <a:r>
               <a:rPr lang="en-US" sz="1200" dirty="0">
                 <a:solidFill>
-                  <a:srgbClr val="9B968C"/>
+                  <a:srgbClr val="002D72"/>
                 </a:solidFill>
                 <a:latin typeface="Calibri" pitchFamily="34" charset="0"/>
                 <a:ea typeface="Calibri" pitchFamily="34" charset="-122"/>
@@ -4090,7 +4090,7 @@
     <p:bg>
       <p:bgPr>
         <a:solidFill>
-          <a:srgbClr val="0F6E67"/>
+          <a:srgbClr val="002D72"/>
         </a:solidFill>
       </p:bgPr>
     </p:bg>
@@ -4135,7 +4135,7 @@
             <a:r>
               <a:rPr lang="en-US" sz="1300" b="1" spc="200" kern="0" dirty="0">
                 <a:solidFill>
-                  <a:srgbClr val="DDEFEC"/>
+                  <a:srgbClr val="DCEBFA"/>
                 </a:solidFill>
                 <a:latin typeface="Calibri" pitchFamily="34" charset="0"/>
                 <a:ea typeface="Calibri" pitchFamily="34" charset="-122"/>
@@ -4219,7 +4219,7 @@
             <a:r>
               <a:rPr lang="en-US" sz="1400" dirty="0">
                 <a:solidFill>
-                  <a:srgbClr val="D7ECE9"/>
+                  <a:srgbClr val="DCEBFA"/>
                 </a:solidFill>
                 <a:latin typeface="Calibri" pitchFamily="34" charset="0"/>
                 <a:ea typeface="Calibri" pitchFamily="34" charset="-122"/>
@@ -4245,7 +4245,7 @@
     <p:bg>
       <p:bgPr>
         <a:solidFill>
-          <a:srgbClr val="12161A"/>
+          <a:srgbClr val="68ACE5"/>
         </a:solidFill>
       </p:bgPr>
     </p:bg>
@@ -4290,7 +4290,7 @@
             <a:r>
               <a:rPr lang="en-US" sz="1400" b="1" spc="200" kern="0" dirty="0">
                 <a:solidFill>
-                  <a:srgbClr val="A3690C"/>
+                  <a:srgbClr val="002D72"/>
                 </a:solidFill>
                 <a:latin typeface="Calibri" pitchFamily="34" charset="0"/>
                 <a:ea typeface="Calibri" pitchFamily="34" charset="-122"/>
@@ -4329,7 +4329,7 @@
             <a:r>
               <a:rPr lang="en-US" sz="11000" b="1" dirty="0">
                 <a:solidFill>
-                  <a:srgbClr val="23282E"/>
+                  <a:srgbClr val="8FC4EE"/>
                 </a:solidFill>
                 <a:latin typeface="Georgia" pitchFamily="34" charset="0"/>
                 <a:ea typeface="Georgia" pitchFamily="34" charset="-122"/>
@@ -4371,7 +4371,7 @@
             <a:r>
               <a:rPr lang="en-US" sz="3800" b="1" dirty="0">
                 <a:solidFill>
-                  <a:srgbClr val="E8E4DB"/>
+                  <a:srgbClr val="002D72"/>
                 </a:solidFill>
                 <a:latin typeface="Georgia" pitchFamily="34" charset="0"/>
                 <a:ea typeface="Georgia" pitchFamily="34" charset="-122"/>
@@ -4413,7 +4413,7 @@
             <a:r>
               <a:rPr lang="en-US" sz="1500" i="1" dirty="0">
                 <a:solidFill>
-                  <a:srgbClr val="9B968C"/>
+                  <a:srgbClr val="002D72"/>
                 </a:solidFill>
                 <a:latin typeface="Calibri" pitchFamily="34" charset="0"/>
                 <a:ea typeface="Calibri" pitchFamily="34" charset="-122"/>
@@ -4439,7 +4439,7 @@
     <p:bg>
       <p:bgPr>
         <a:solidFill>
-          <a:srgbClr val="F7F5F0"/>
+          <a:srgbClr val="F5F8FC"/>
         </a:solidFill>
       </p:bgPr>
     </p:bg>
@@ -4484,7 +4484,7 @@
             <a:r>
               <a:rPr lang="en-US" sz="1200" b="1" spc="150" kern="0" dirty="0">
                 <a:solidFill>
-                  <a:srgbClr val="A3690C"/>
+                  <a:srgbClr val="964F2E"/>
                 </a:solidFill>
                 <a:latin typeface="Calibri" pitchFamily="34" charset="0"/>
                 <a:ea typeface="Calibri" pitchFamily="34" charset="-122"/>
@@ -4523,7 +4523,7 @@
             <a:r>
               <a:rPr lang="en-US" sz="3000" b="1" dirty="0">
                 <a:solidFill>
-                  <a:srgbClr val="201D18"/>
+                  <a:srgbClr val="002D72"/>
                 </a:solidFill>
                 <a:latin typeface="Georgia" pitchFamily="34" charset="0"/>
                 <a:ea typeface="Georgia" pitchFamily="34" charset="-122"/>
@@ -4569,7 +4569,7 @@
             <a:r>
               <a:rPr lang="en-US" sz="1700" dirty="0">
                 <a:solidFill>
-                  <a:srgbClr val="201D18"/>
+                  <a:srgbClr val="002D72"/>
                 </a:solidFill>
                 <a:latin typeface="Calibri" pitchFamily="34" charset="0"/>
                 <a:ea typeface="Calibri" pitchFamily="34" charset="-122"/>
@@ -4593,7 +4593,7 @@
             <a:r>
               <a:rPr lang="en-US" sz="1700" dirty="0">
                 <a:solidFill>
-                  <a:srgbClr val="201D18"/>
+                  <a:srgbClr val="002D72"/>
                 </a:solidFill>
                 <a:latin typeface="Calibri" pitchFamily="34" charset="0"/>
                 <a:ea typeface="Calibri" pitchFamily="34" charset="-122"/>
@@ -4617,7 +4617,7 @@
             <a:r>
               <a:rPr lang="en-US" sz="1700" dirty="0">
                 <a:solidFill>
-                  <a:srgbClr val="201D18"/>
+                  <a:srgbClr val="002D72"/>
                 </a:solidFill>
                 <a:latin typeface="Calibri" pitchFamily="34" charset="0"/>
                 <a:ea typeface="Calibri" pitchFamily="34" charset="-122"/>
@@ -4641,7 +4641,7 @@
             <a:r>
               <a:rPr lang="en-US" sz="1700" dirty="0">
                 <a:solidFill>
-                  <a:srgbClr val="201D18"/>
+                  <a:srgbClr val="002D72"/>
                 </a:solidFill>
                 <a:latin typeface="Calibri" pitchFamily="34" charset="0"/>
                 <a:ea typeface="Calibri" pitchFamily="34" charset="-122"/>
@@ -4680,7 +4680,7 @@
             <a:r>
               <a:rPr lang="en-US" sz="1000" dirty="0">
                 <a:solidFill>
-                  <a:srgbClr val="6B6860"/>
+                  <a:srgbClr val="4A6B8A"/>
                 </a:solidFill>
                 <a:latin typeface="Calibri" pitchFamily="34" charset="0"/>
                 <a:ea typeface="Calibri" pitchFamily="34" charset="-122"/>
@@ -4694,7 +4694,7 @@
             <a:r>
               <a:rPr lang="en-US" sz="1000" u="sng" dirty="0">
                 <a:solidFill>
-                  <a:srgbClr val="6B6860"/>
+                  <a:srgbClr val="4A6B8A"/>
                 </a:solidFill>
                 <a:latin typeface="Calibri" pitchFamily="34" charset="0"/>
                 <a:ea typeface="Calibri" pitchFamily="34" charset="-122"/>
@@ -4740,7 +4740,7 @@
             <a:r>
               <a:rPr lang="en-US" sz="1000" dirty="0">
                 <a:solidFill>
-                  <a:srgbClr val="6B6860"/>
+                  <a:srgbClr val="4A6B8A"/>
                 </a:solidFill>
                 <a:latin typeface="Calibri" pitchFamily="34" charset="0"/>
                 <a:ea typeface="Calibri" pitchFamily="34" charset="-122"/>
@@ -4766,7 +4766,7 @@
     <p:bg>
       <p:bgPr>
         <a:solidFill>
-          <a:srgbClr val="F7F5F0"/>
+          <a:srgbClr val="F5F8FC"/>
         </a:solidFill>
       </p:bgPr>
     </p:bg>
@@ -4811,7 +4811,7 @@
             <a:r>
               <a:rPr lang="en-US" sz="1200" b="1" spc="150" kern="0" dirty="0">
                 <a:solidFill>
-                  <a:srgbClr val="A3690C"/>
+                  <a:srgbClr val="964F2E"/>
                 </a:solidFill>
                 <a:latin typeface="Calibri" pitchFamily="34" charset="0"/>
                 <a:ea typeface="Calibri" pitchFamily="34" charset="-122"/>
@@ -4850,7 +4850,7 @@
             <a:r>
               <a:rPr lang="en-US" sz="3000" b="1" dirty="0">
                 <a:solidFill>
-                  <a:srgbClr val="201D18"/>
+                  <a:srgbClr val="002D72"/>
                 </a:solidFill>
                 <a:latin typeface="Georgia" pitchFamily="34" charset="0"/>
                 <a:ea typeface="Georgia" pitchFamily="34" charset="-122"/>
@@ -4881,7 +4881,7 @@
           </a:solidFill>
           <a:ln w="12700">
             <a:solidFill>
-              <a:srgbClr val="E2DDD2"/>
+              <a:srgbClr val="D6E4F2"/>
             </a:solidFill>
             <a:prstDash val="solid"/>
           </a:ln>
@@ -4917,7 +4917,7 @@
             <a:r>
               <a:rPr lang="en-US" sz="2000" b="1" dirty="0">
                 <a:solidFill>
-                  <a:srgbClr val="0F6E67"/>
+                  <a:srgbClr val="002D72"/>
                 </a:solidFill>
                 <a:latin typeface="Georgia" pitchFamily="34" charset="0"/>
                 <a:ea typeface="Georgia" pitchFamily="34" charset="-122"/>
@@ -4956,7 +4956,7 @@
             <a:r>
               <a:rPr lang="en-US" sz="1200" b="1" dirty="0">
                 <a:solidFill>
-                  <a:srgbClr val="A3690C"/>
+                  <a:srgbClr val="964F2E"/>
                 </a:solidFill>
                 <a:latin typeface="Calibri" pitchFamily="34" charset="0"/>
                 <a:ea typeface="Calibri" pitchFamily="34" charset="-122"/>
@@ -4998,7 +4998,7 @@
             <a:r>
               <a:rPr lang="en-US" sz="1400" dirty="0">
                 <a:solidFill>
-                  <a:srgbClr val="201D18"/>
+                  <a:srgbClr val="002D72"/>
                 </a:solidFill>
                 <a:latin typeface="Calibri" pitchFamily="34" charset="0"/>
                 <a:ea typeface="Calibri" pitchFamily="34" charset="-122"/>
@@ -5029,7 +5029,7 @@
           </a:solidFill>
           <a:ln w="12700">
             <a:solidFill>
-              <a:srgbClr val="E2DDD2"/>
+              <a:srgbClr val="D6E4F2"/>
             </a:solidFill>
             <a:prstDash val="solid"/>
           </a:ln>
@@ -5065,7 +5065,7 @@
             <a:r>
               <a:rPr lang="en-US" sz="2000" b="1" dirty="0">
                 <a:solidFill>
-                  <a:srgbClr val="0F6E67"/>
+                  <a:srgbClr val="002D72"/>
                 </a:solidFill>
                 <a:latin typeface="Georgia" pitchFamily="34" charset="0"/>
                 <a:ea typeface="Georgia" pitchFamily="34" charset="-122"/>
@@ -5104,7 +5104,7 @@
             <a:r>
               <a:rPr lang="en-US" sz="1200" b="1" dirty="0">
                 <a:solidFill>
-                  <a:srgbClr val="A3690C"/>
+                  <a:srgbClr val="964F2E"/>
                 </a:solidFill>
                 <a:latin typeface="Calibri" pitchFamily="34" charset="0"/>
                 <a:ea typeface="Calibri" pitchFamily="34" charset="-122"/>
@@ -5146,7 +5146,7 @@
             <a:r>
               <a:rPr lang="en-US" sz="1400" dirty="0">
                 <a:solidFill>
-                  <a:srgbClr val="201D18"/>
+                  <a:srgbClr val="002D72"/>
                 </a:solidFill>
                 <a:latin typeface="Calibri" pitchFamily="34" charset="0"/>
                 <a:ea typeface="Calibri" pitchFamily="34" charset="-122"/>
@@ -5185,7 +5185,7 @@
             <a:r>
               <a:rPr lang="en-US" sz="1000" dirty="0">
                 <a:solidFill>
-                  <a:srgbClr val="6B6860"/>
+                  <a:srgbClr val="4A6B8A"/>
                 </a:solidFill>
                 <a:latin typeface="Calibri" pitchFamily="34" charset="0"/>
                 <a:ea typeface="Calibri" pitchFamily="34" charset="-122"/>
@@ -5199,7 +5199,7 @@
             <a:r>
               <a:rPr lang="en-US" sz="1000" u="sng" dirty="0">
                 <a:solidFill>
-                  <a:srgbClr val="6B6860"/>
+                  <a:srgbClr val="4A6B8A"/>
                 </a:solidFill>
                 <a:latin typeface="Calibri" pitchFamily="34" charset="0"/>
                 <a:ea typeface="Calibri" pitchFamily="34" charset="-122"/>
@@ -5220,7 +5220,7 @@
             <a:r>
               <a:rPr lang="en-US" sz="1000" dirty="0">
                 <a:solidFill>
-                  <a:srgbClr val="6B6860"/>
+                  <a:srgbClr val="4A6B8A"/>
                 </a:solidFill>
                 <a:latin typeface="Calibri" pitchFamily="34" charset="0"/>
                 <a:ea typeface="Calibri" pitchFamily="34" charset="-122"/>
@@ -5234,7 +5234,7 @@
             <a:r>
               <a:rPr lang="en-US" sz="1000" u="sng" dirty="0">
                 <a:solidFill>
-                  <a:srgbClr val="6B6860"/>
+                  <a:srgbClr val="4A6B8A"/>
                 </a:solidFill>
                 <a:latin typeface="Calibri" pitchFamily="34" charset="0"/>
                 <a:ea typeface="Calibri" pitchFamily="34" charset="-122"/>
@@ -5280,7 +5280,7 @@
             <a:r>
               <a:rPr lang="en-US" sz="1000" dirty="0">
                 <a:solidFill>
-                  <a:srgbClr val="6B6860"/>
+                  <a:srgbClr val="4A6B8A"/>
                 </a:solidFill>
                 <a:latin typeface="Calibri" pitchFamily="34" charset="0"/>
                 <a:ea typeface="Calibri" pitchFamily="34" charset="-122"/>
@@ -5306,7 +5306,7 @@
     <p:bg>
       <p:bgPr>
         <a:solidFill>
-          <a:srgbClr val="F7F5F0"/>
+          <a:srgbClr val="F5F8FC"/>
         </a:solidFill>
       </p:bgPr>
     </p:bg>
@@ -5351,7 +5351,7 @@
             <a:r>
               <a:rPr lang="en-US" sz="1200" b="1" spc="150" kern="0" dirty="0">
                 <a:solidFill>
-                  <a:srgbClr val="A3690C"/>
+                  <a:srgbClr val="964F2E"/>
                 </a:solidFill>
                 <a:latin typeface="Calibri" pitchFamily="34" charset="0"/>
                 <a:ea typeface="Calibri" pitchFamily="34" charset="-122"/>
@@ -5390,7 +5390,7 @@
             <a:r>
               <a:rPr lang="en-US" sz="3000" b="1" dirty="0">
                 <a:solidFill>
-                  <a:srgbClr val="201D18"/>
+                  <a:srgbClr val="002D72"/>
                 </a:solidFill>
                 <a:latin typeface="Georgia" pitchFamily="34" charset="0"/>
                 <a:ea typeface="Georgia" pitchFamily="34" charset="-122"/>
@@ -5421,7 +5421,7 @@
           </a:solidFill>
           <a:ln w="12700">
             <a:solidFill>
-              <a:srgbClr val="E2DDD2"/>
+              <a:srgbClr val="D6E4F2"/>
             </a:solidFill>
             <a:prstDash val="solid"/>
           </a:ln>
@@ -5454,7 +5454,7 @@
             <a:r>
               <a:rPr lang="en-US" sz="6000" b="1" dirty="0">
                 <a:solidFill>
-                  <a:srgbClr val="A3690C"/>
+                  <a:srgbClr val="964F2E"/>
                 </a:solidFill>
                 <a:latin typeface="Georgia" pitchFamily="34" charset="0"/>
                 <a:ea typeface="Georgia" pitchFamily="34" charset="-122"/>
@@ -5496,7 +5496,7 @@
             <a:r>
               <a:rPr lang="en-US" sz="1150" dirty="0">
                 <a:solidFill>
-                  <a:srgbClr val="6B6860"/>
+                  <a:srgbClr val="4A6B8A"/>
                 </a:solidFill>
                 <a:latin typeface="Calibri" pitchFamily="34" charset="0"/>
                 <a:ea typeface="Calibri" pitchFamily="34" charset="-122"/>
@@ -5516,7 +5516,7 @@
             <a:r>
               <a:rPr lang="en-US" sz="1150" dirty="0">
                 <a:solidFill>
-                  <a:srgbClr val="6B6860"/>
+                  <a:srgbClr val="4A6B8A"/>
                 </a:solidFill>
                 <a:latin typeface="Calibri" pitchFamily="34" charset="0"/>
                 <a:ea typeface="Calibri" pitchFamily="34" charset="-122"/>
@@ -5547,7 +5547,7 @@
           </a:solidFill>
           <a:ln w="12700">
             <a:solidFill>
-              <a:srgbClr val="E2DDD2"/>
+              <a:srgbClr val="D6E4F2"/>
             </a:solidFill>
             <a:prstDash val="solid"/>
           </a:ln>
@@ -5580,7 +5580,7 @@
             <a:r>
               <a:rPr lang="en-US" sz="6000" b="1" dirty="0">
                 <a:solidFill>
-                  <a:srgbClr val="0F6E67"/>
+                  <a:srgbClr val="002D72"/>
                 </a:solidFill>
                 <a:latin typeface="Georgia" pitchFamily="34" charset="0"/>
                 <a:ea typeface="Georgia" pitchFamily="34" charset="-122"/>
@@ -5622,7 +5622,7 @@
             <a:r>
               <a:rPr lang="en-US" sz="1150" dirty="0">
                 <a:solidFill>
-                  <a:srgbClr val="6B6860"/>
+                  <a:srgbClr val="4A6B8A"/>
                 </a:solidFill>
                 <a:latin typeface="Calibri" pitchFamily="34" charset="0"/>
                 <a:ea typeface="Calibri" pitchFamily="34" charset="-122"/>
@@ -5642,7 +5642,7 @@
             <a:r>
               <a:rPr lang="en-US" sz="1150" dirty="0">
                 <a:solidFill>
-                  <a:srgbClr val="6B6860"/>
+                  <a:srgbClr val="4A6B8A"/>
                 </a:solidFill>
                 <a:latin typeface="Calibri" pitchFamily="34" charset="0"/>
                 <a:ea typeface="Calibri" pitchFamily="34" charset="-122"/>
@@ -5684,7 +5684,7 @@
             <a:r>
               <a:rPr lang="en-US" sz="1500" i="1" dirty="0">
                 <a:solidFill>
-                  <a:srgbClr val="201D18"/>
+                  <a:srgbClr val="002D72"/>
                 </a:solidFill>
                 <a:latin typeface="Calibri" pitchFamily="34" charset="0"/>
                 <a:ea typeface="Calibri" pitchFamily="34" charset="-122"/>
@@ -5723,7 +5723,7 @@
             <a:r>
               <a:rPr lang="en-US" sz="1000" dirty="0">
                 <a:solidFill>
-                  <a:srgbClr val="6B6860"/>
+                  <a:srgbClr val="4A6B8A"/>
                 </a:solidFill>
                 <a:latin typeface="Calibri" pitchFamily="34" charset="0"/>
                 <a:ea typeface="Calibri" pitchFamily="34" charset="-122"/>
@@ -5737,7 +5737,7 @@
             <a:r>
               <a:rPr lang="en-US" sz="1000" u="sng" dirty="0">
                 <a:solidFill>
-                  <a:srgbClr val="6B6860"/>
+                  <a:srgbClr val="4A6B8A"/>
                 </a:solidFill>
                 <a:latin typeface="Calibri" pitchFamily="34" charset="0"/>
                 <a:ea typeface="Calibri" pitchFamily="34" charset="-122"/>
@@ -5783,7 +5783,7 @@
             <a:r>
               <a:rPr lang="en-US" sz="1000" dirty="0">
                 <a:solidFill>
-                  <a:srgbClr val="6B6860"/>
+                  <a:srgbClr val="4A6B8A"/>
                 </a:solidFill>
                 <a:latin typeface="Calibri" pitchFamily="34" charset="0"/>
                 <a:ea typeface="Calibri" pitchFamily="34" charset="-122"/>
@@ -5809,7 +5809,7 @@
     <p:bg>
       <p:bgPr>
         <a:solidFill>
-          <a:srgbClr val="0F6E67"/>
+          <a:srgbClr val="002D72"/>
         </a:solidFill>
       </p:bgPr>
     </p:bg>
@@ -5854,7 +5854,7 @@
             <a:r>
               <a:rPr lang="en-US" sz="1300" b="1" spc="200" kern="0" dirty="0">
                 <a:solidFill>
-                  <a:srgbClr val="DDEFEC"/>
+                  <a:srgbClr val="DCEBFA"/>
                 </a:solidFill>
                 <a:latin typeface="Calibri" pitchFamily="34" charset="0"/>
                 <a:ea typeface="Calibri" pitchFamily="34" charset="-122"/>
@@ -5938,7 +5938,7 @@
             <a:r>
               <a:rPr lang="en-US" sz="1400" dirty="0">
                 <a:solidFill>
-                  <a:srgbClr val="D7ECE9"/>
+                  <a:srgbClr val="DCEBFA"/>
                 </a:solidFill>
                 <a:latin typeface="Calibri" pitchFamily="34" charset="0"/>
                 <a:ea typeface="Calibri" pitchFamily="34" charset="-122"/>
@@ -5964,7 +5964,7 @@
     <p:bg>
       <p:bgPr>
         <a:solidFill>
-          <a:srgbClr val="12161A"/>
+          <a:srgbClr val="68ACE5"/>
         </a:solidFill>
       </p:bgPr>
     </p:bg>
@@ -6009,7 +6009,7 @@
             <a:r>
               <a:rPr lang="en-US" sz="1400" b="1" spc="200" kern="0" dirty="0">
                 <a:solidFill>
-                  <a:srgbClr val="A3690C"/>
+                  <a:srgbClr val="002D72"/>
                 </a:solidFill>
                 <a:latin typeface="Calibri" pitchFamily="34" charset="0"/>
                 <a:ea typeface="Calibri" pitchFamily="34" charset="-122"/>
@@ -6048,7 +6048,7 @@
             <a:r>
               <a:rPr lang="en-US" sz="11000" b="1" dirty="0">
                 <a:solidFill>
-                  <a:srgbClr val="23282E"/>
+                  <a:srgbClr val="8FC4EE"/>
                 </a:solidFill>
                 <a:latin typeface="Georgia" pitchFamily="34" charset="0"/>
                 <a:ea typeface="Georgia" pitchFamily="34" charset="-122"/>
@@ -6090,7 +6090,7 @@
             <a:r>
               <a:rPr lang="en-US" sz="3800" b="1" dirty="0">
                 <a:solidFill>
-                  <a:srgbClr val="E8E4DB"/>
+                  <a:srgbClr val="002D72"/>
                 </a:solidFill>
                 <a:latin typeface="Georgia" pitchFamily="34" charset="0"/>
                 <a:ea typeface="Georgia" pitchFamily="34" charset="-122"/>
@@ -6132,7 +6132,7 @@
             <a:r>
               <a:rPr lang="en-US" sz="1500" i="1" dirty="0">
                 <a:solidFill>
-                  <a:srgbClr val="9B968C"/>
+                  <a:srgbClr val="002D72"/>
                 </a:solidFill>
                 <a:latin typeface="Calibri" pitchFamily="34" charset="0"/>
                 <a:ea typeface="Calibri" pitchFamily="34" charset="-122"/>
@@ -6158,7 +6158,7 @@
     <p:bg>
       <p:bgPr>
         <a:solidFill>
-          <a:srgbClr val="F7F5F0"/>
+          <a:srgbClr val="F5F8FC"/>
         </a:solidFill>
       </p:bgPr>
     </p:bg>
@@ -6203,7 +6203,7 @@
             <a:r>
               <a:rPr lang="en-US" sz="1200" b="1" spc="150" kern="0" dirty="0">
                 <a:solidFill>
-                  <a:srgbClr val="A3690C"/>
+                  <a:srgbClr val="964F2E"/>
                 </a:solidFill>
                 <a:latin typeface="Calibri" pitchFamily="34" charset="0"/>
                 <a:ea typeface="Calibri" pitchFamily="34" charset="-122"/>
@@ -6245,7 +6245,7 @@
             <a:r>
               <a:rPr lang="en-US" sz="3000" b="1" i="1" dirty="0">
                 <a:solidFill>
-                  <a:srgbClr val="201D18"/>
+                  <a:srgbClr val="002D72"/>
                 </a:solidFill>
                 <a:latin typeface="Georgia" pitchFamily="34" charset="0"/>
                 <a:ea typeface="Georgia" pitchFamily="34" charset="-122"/>
@@ -6274,7 +6274,7 @@
           <a:noFill/>
           <a:ln w="25400">
             <a:solidFill>
-              <a:srgbClr val="A3690C"/>
+              <a:srgbClr val="F1C400"/>
             </a:solidFill>
             <a:prstDash val="solid"/>
           </a:ln>
@@ -6307,7 +6307,7 @@
             <a:r>
               <a:rPr lang="en-US" sz="1400" dirty="0">
                 <a:solidFill>
-                  <a:srgbClr val="6B6860"/>
+                  <a:srgbClr val="4A6B8A"/>
                 </a:solidFill>
                 <a:latin typeface="Calibri" pitchFamily="34" charset="0"/>
                 <a:ea typeface="Calibri" pitchFamily="34" charset="-122"/>
@@ -6346,7 +6346,7 @@
             <a:r>
               <a:rPr lang="en-US" sz="1000" dirty="0">
                 <a:solidFill>
-                  <a:srgbClr val="6B6860"/>
+                  <a:srgbClr val="4A6B8A"/>
                 </a:solidFill>
                 <a:latin typeface="Calibri" pitchFamily="34" charset="0"/>
                 <a:ea typeface="Calibri" pitchFamily="34" charset="-122"/>
@@ -6360,7 +6360,7 @@
             <a:r>
               <a:rPr lang="en-US" sz="1000" u="sng" dirty="0">
                 <a:solidFill>
-                  <a:srgbClr val="6B6860"/>
+                  <a:srgbClr val="4A6B8A"/>
                 </a:solidFill>
                 <a:latin typeface="Calibri" pitchFamily="34" charset="0"/>
                 <a:ea typeface="Calibri" pitchFamily="34" charset="-122"/>
@@ -6406,7 +6406,7 @@
             <a:r>
               <a:rPr lang="en-US" sz="1000" dirty="0">
                 <a:solidFill>
-                  <a:srgbClr val="6B6860"/>
+                  <a:srgbClr val="4A6B8A"/>
                 </a:solidFill>
                 <a:latin typeface="Calibri" pitchFamily="34" charset="0"/>
                 <a:ea typeface="Calibri" pitchFamily="34" charset="-122"/>
@@ -6432,7 +6432,7 @@
     <p:bg>
       <p:bgPr>
         <a:solidFill>
-          <a:srgbClr val="F7F5F0"/>
+          <a:srgbClr val="F5F8FC"/>
         </a:solidFill>
       </p:bgPr>
     </p:bg>
@@ -6477,7 +6477,7 @@
             <a:r>
               <a:rPr lang="en-US" sz="1200" b="1" spc="150" kern="0" dirty="0">
                 <a:solidFill>
-                  <a:srgbClr val="A3690C"/>
+                  <a:srgbClr val="964F2E"/>
                 </a:solidFill>
                 <a:latin typeface="Calibri" pitchFamily="34" charset="0"/>
                 <a:ea typeface="Calibri" pitchFamily="34" charset="-122"/>
@@ -6516,7 +6516,7 @@
             <a:r>
               <a:rPr lang="en-US" sz="3000" b="1" dirty="0">
                 <a:solidFill>
-                  <a:srgbClr val="201D18"/>
+                  <a:srgbClr val="002D72"/>
                 </a:solidFill>
                 <a:latin typeface="Georgia" pitchFamily="34" charset="0"/>
                 <a:ea typeface="Georgia" pitchFamily="34" charset="-122"/>
@@ -6555,7 +6555,7 @@
             <a:r>
               <a:rPr lang="en-US" sz="1300" dirty="0">
                 <a:solidFill>
-                  <a:srgbClr val="6B6860"/>
+                  <a:srgbClr val="4A6B8A"/>
                 </a:solidFill>
                 <a:latin typeface="Calibri" pitchFamily="34" charset="0"/>
                 <a:ea typeface="Calibri" pitchFamily="34" charset="-122"/>
@@ -6586,7 +6586,7 @@
           </a:solidFill>
           <a:ln w="12700">
             <a:solidFill>
-              <a:srgbClr val="E2DDD2"/>
+              <a:srgbClr val="D6E4F2"/>
             </a:solidFill>
             <a:prstDash val="solid"/>
           </a:ln>
@@ -6622,7 +6622,7 @@
             <a:r>
               <a:rPr lang="en-US" sz="1500" b="1" dirty="0">
                 <a:solidFill>
-                  <a:srgbClr val="201D18"/>
+                  <a:srgbClr val="002D72"/>
                 </a:solidFill>
                 <a:latin typeface="Calibri" pitchFamily="34" charset="0"/>
                 <a:ea typeface="Calibri" pitchFamily="34" charset="-122"/>
@@ -6642,7 +6642,7 @@
             <a:r>
               <a:rPr lang="en-US" sz="1500" b="1" dirty="0">
                 <a:solidFill>
-                  <a:srgbClr val="201D18"/>
+                  <a:srgbClr val="002D72"/>
                 </a:solidFill>
                 <a:latin typeface="Calibri" pitchFamily="34" charset="0"/>
                 <a:ea typeface="Calibri" pitchFamily="34" charset="-122"/>
@@ -6681,7 +6681,7 @@
             <a:r>
               <a:rPr lang="en-US" sz="1100" dirty="0">
                 <a:solidFill>
-                  <a:srgbClr val="6B6860"/>
+                  <a:srgbClr val="4A6B8A"/>
                 </a:solidFill>
                 <a:latin typeface="Calibri" pitchFamily="34" charset="0"/>
                 <a:ea typeface="Calibri" pitchFamily="34" charset="-122"/>
@@ -6720,7 +6720,7 @@
             <a:r>
               <a:rPr lang="en-US" sz="3400" b="1" dirty="0">
                 <a:solidFill>
-                  <a:srgbClr val="6B6860"/>
+                  <a:srgbClr val="4A6B8A"/>
                 </a:solidFill>
                 <a:latin typeface="Georgia" pitchFamily="34" charset="0"/>
                 <a:ea typeface="Georgia" pitchFamily="34" charset="-122"/>
@@ -6759,7 +6759,7 @@
             <a:r>
               <a:rPr lang="en-US" sz="1100" dirty="0">
                 <a:solidFill>
-                  <a:srgbClr val="6B6860"/>
+                  <a:srgbClr val="4A6B8A"/>
                 </a:solidFill>
                 <a:latin typeface="Calibri" pitchFamily="34" charset="0"/>
                 <a:ea typeface="Calibri" pitchFamily="34" charset="-122"/>
@@ -6798,7 +6798,7 @@
             <a:r>
               <a:rPr lang="en-US" sz="3400" b="1" dirty="0">
                 <a:solidFill>
-                  <a:srgbClr val="6B6860"/>
+                  <a:srgbClr val="4A6B8A"/>
                 </a:solidFill>
                 <a:latin typeface="Georgia" pitchFamily="34" charset="0"/>
                 <a:ea typeface="Georgia" pitchFamily="34" charset="-122"/>
@@ -6829,7 +6829,7 @@
           </a:solidFill>
           <a:ln w="12700">
             <a:solidFill>
-              <a:srgbClr val="E2DDD2"/>
+              <a:srgbClr val="D6E4F2"/>
             </a:solidFill>
             <a:prstDash val="solid"/>
           </a:ln>
@@ -6865,7 +6865,7 @@
             <a:r>
               <a:rPr lang="en-US" sz="1500" b="1" dirty="0">
                 <a:solidFill>
-                  <a:srgbClr val="201D18"/>
+                  <a:srgbClr val="002D72"/>
                 </a:solidFill>
                 <a:latin typeface="Calibri" pitchFamily="34" charset="0"/>
                 <a:ea typeface="Calibri" pitchFamily="34" charset="-122"/>
@@ -6885,7 +6885,7 @@
             <a:r>
               <a:rPr lang="en-US" sz="1500" b="1" dirty="0">
                 <a:solidFill>
-                  <a:srgbClr val="201D18"/>
+                  <a:srgbClr val="002D72"/>
                 </a:solidFill>
                 <a:latin typeface="Calibri" pitchFamily="34" charset="0"/>
                 <a:ea typeface="Calibri" pitchFamily="34" charset="-122"/>
@@ -6924,7 +6924,7 @@
             <a:r>
               <a:rPr lang="en-US" sz="1100" dirty="0">
                 <a:solidFill>
-                  <a:srgbClr val="6B6860"/>
+                  <a:srgbClr val="4A6B8A"/>
                 </a:solidFill>
                 <a:latin typeface="Calibri" pitchFamily="34" charset="0"/>
                 <a:ea typeface="Calibri" pitchFamily="34" charset="-122"/>
@@ -6963,7 +6963,7 @@
             <a:r>
               <a:rPr lang="en-US" sz="3400" b="1" dirty="0">
                 <a:solidFill>
-                  <a:srgbClr val="A3690C"/>
+                  <a:srgbClr val="964F2E"/>
                 </a:solidFill>
                 <a:latin typeface="Georgia" pitchFamily="34" charset="0"/>
                 <a:ea typeface="Georgia" pitchFamily="34" charset="-122"/>
@@ -7002,7 +7002,7 @@
             <a:r>
               <a:rPr lang="en-US" sz="1100" dirty="0">
                 <a:solidFill>
-                  <a:srgbClr val="6B6860"/>
+                  <a:srgbClr val="4A6B8A"/>
                 </a:solidFill>
                 <a:latin typeface="Calibri" pitchFamily="34" charset="0"/>
                 <a:ea typeface="Calibri" pitchFamily="34" charset="-122"/>
@@ -7041,7 +7041,7 @@
             <a:r>
               <a:rPr lang="en-US" sz="3400" b="1" dirty="0">
                 <a:solidFill>
-                  <a:srgbClr val="A3690C"/>
+                  <a:srgbClr val="964F2E"/>
                 </a:solidFill>
                 <a:latin typeface="Georgia" pitchFamily="34" charset="0"/>
                 <a:ea typeface="Georgia" pitchFamily="34" charset="-122"/>
@@ -7083,7 +7083,7 @@
             <a:r>
               <a:rPr lang="en-US" sz="1300" i="1" dirty="0">
                 <a:solidFill>
-                  <a:srgbClr val="201D18"/>
+                  <a:srgbClr val="002D72"/>
                 </a:solidFill>
                 <a:latin typeface="Calibri" pitchFamily="34" charset="0"/>
                 <a:ea typeface="Calibri" pitchFamily="34" charset="-122"/>
@@ -7122,7 +7122,7 @@
             <a:r>
               <a:rPr lang="en-US" sz="1000" dirty="0">
                 <a:solidFill>
-                  <a:srgbClr val="6B6860"/>
+                  <a:srgbClr val="4A6B8A"/>
                 </a:solidFill>
                 <a:latin typeface="Calibri" pitchFamily="34" charset="0"/>
                 <a:ea typeface="Calibri" pitchFamily="34" charset="-122"/>
@@ -7136,7 +7136,7 @@
             <a:r>
               <a:rPr lang="en-US" sz="1000" u="sng" dirty="0">
                 <a:solidFill>
-                  <a:srgbClr val="6B6860"/>
+                  <a:srgbClr val="4A6B8A"/>
                 </a:solidFill>
                 <a:latin typeface="Calibri" pitchFamily="34" charset="0"/>
                 <a:ea typeface="Calibri" pitchFamily="34" charset="-122"/>
@@ -7182,7 +7182,7 @@
             <a:r>
               <a:rPr lang="en-US" sz="1000" dirty="0">
                 <a:solidFill>
-                  <a:srgbClr val="6B6860"/>
+                  <a:srgbClr val="4A6B8A"/>
                 </a:solidFill>
                 <a:latin typeface="Calibri" pitchFamily="34" charset="0"/>
                 <a:ea typeface="Calibri" pitchFamily="34" charset="-122"/>
@@ -7208,7 +7208,7 @@
     <p:bg>
       <p:bgPr>
         <a:solidFill>
-          <a:srgbClr val="F7F5F0"/>
+          <a:srgbClr val="F5F8FC"/>
         </a:solidFill>
       </p:bgPr>
     </p:bg>
@@ -7253,7 +7253,7 @@
             <a:r>
               <a:rPr lang="en-US" sz="1200" b="1" spc="150" kern="0" dirty="0">
                 <a:solidFill>
-                  <a:srgbClr val="A3690C"/>
+                  <a:srgbClr val="964F2E"/>
                 </a:solidFill>
                 <a:latin typeface="Calibri" pitchFamily="34" charset="0"/>
                 <a:ea typeface="Calibri" pitchFamily="34" charset="-122"/>
@@ -7292,7 +7292,7 @@
             <a:r>
               <a:rPr lang="en-US" sz="3000" b="1" dirty="0">
                 <a:solidFill>
-                  <a:srgbClr val="201D18"/>
+                  <a:srgbClr val="002D72"/>
                 </a:solidFill>
                 <a:latin typeface="Georgia" pitchFamily="34" charset="0"/>
                 <a:ea typeface="Georgia" pitchFamily="34" charset="-122"/>
@@ -7323,7 +7323,7 @@
           </a:solidFill>
           <a:ln w="12700">
             <a:solidFill>
-              <a:srgbClr val="E2DDD2"/>
+              <a:srgbClr val="D6E4F2"/>
             </a:solidFill>
             <a:prstDash val="solid"/>
           </a:ln>
@@ -7356,7 +7356,7 @@
             <a:r>
               <a:rPr lang="en-US" sz="3200" b="1" dirty="0">
                 <a:solidFill>
-                  <a:srgbClr val="0F6E67"/>
+                  <a:srgbClr val="002D72"/>
                 </a:solidFill>
                 <a:latin typeface="Georgia" pitchFamily="34" charset="0"/>
                 <a:ea typeface="Georgia" pitchFamily="34" charset="-122"/>
@@ -7398,7 +7398,7 @@
             <a:r>
               <a:rPr lang="en-US" sz="1150" dirty="0">
                 <a:solidFill>
-                  <a:srgbClr val="6B6860"/>
+                  <a:srgbClr val="4A6B8A"/>
                 </a:solidFill>
                 <a:latin typeface="Calibri" pitchFamily="34" charset="0"/>
                 <a:ea typeface="Calibri" pitchFamily="34" charset="-122"/>
@@ -7418,7 +7418,7 @@
             <a:r>
               <a:rPr lang="en-US" sz="1150" dirty="0">
                 <a:solidFill>
-                  <a:srgbClr val="6B6860"/>
+                  <a:srgbClr val="4A6B8A"/>
                 </a:solidFill>
                 <a:latin typeface="Calibri" pitchFamily="34" charset="0"/>
                 <a:ea typeface="Calibri" pitchFamily="34" charset="-122"/>
@@ -7449,7 +7449,7 @@
           </a:solidFill>
           <a:ln w="12700">
             <a:solidFill>
-              <a:srgbClr val="E2DDD2"/>
+              <a:srgbClr val="D6E4F2"/>
             </a:solidFill>
             <a:prstDash val="solid"/>
           </a:ln>
@@ -7482,7 +7482,7 @@
             <a:r>
               <a:rPr lang="en-US" sz="3200" b="1" dirty="0">
                 <a:solidFill>
-                  <a:srgbClr val="5C5750"/>
+                  <a:srgbClr val="4A6B8A"/>
                 </a:solidFill>
                 <a:latin typeface="Georgia" pitchFamily="34" charset="0"/>
                 <a:ea typeface="Georgia" pitchFamily="34" charset="-122"/>
@@ -7524,7 +7524,7 @@
             <a:r>
               <a:rPr lang="en-US" sz="1150" dirty="0">
                 <a:solidFill>
-                  <a:srgbClr val="6B6860"/>
+                  <a:srgbClr val="4A6B8A"/>
                 </a:solidFill>
                 <a:latin typeface="Calibri" pitchFamily="34" charset="0"/>
                 <a:ea typeface="Calibri" pitchFamily="34" charset="-122"/>
@@ -7544,7 +7544,7 @@
             <a:r>
               <a:rPr lang="en-US" sz="1150" dirty="0">
                 <a:solidFill>
-                  <a:srgbClr val="6B6860"/>
+                  <a:srgbClr val="4A6B8A"/>
                 </a:solidFill>
                 <a:latin typeface="Calibri" pitchFamily="34" charset="0"/>
                 <a:ea typeface="Calibri" pitchFamily="34" charset="-122"/>
@@ -7586,7 +7586,7 @@
             <a:r>
               <a:rPr lang="en-US" sz="1400" i="1" dirty="0">
                 <a:solidFill>
-                  <a:srgbClr val="201D18"/>
+                  <a:srgbClr val="002D72"/>
                 </a:solidFill>
                 <a:latin typeface="Calibri" pitchFamily="34" charset="0"/>
                 <a:ea typeface="Calibri" pitchFamily="34" charset="-122"/>
@@ -7625,7 +7625,7 @@
             <a:r>
               <a:rPr lang="en-US" sz="1000" dirty="0">
                 <a:solidFill>
-                  <a:srgbClr val="6B6860"/>
+                  <a:srgbClr val="4A6B8A"/>
                 </a:solidFill>
                 <a:latin typeface="Calibri" pitchFamily="34" charset="0"/>
                 <a:ea typeface="Calibri" pitchFamily="34" charset="-122"/>
@@ -7639,7 +7639,7 @@
             <a:r>
               <a:rPr lang="en-US" sz="1000" u="sng" dirty="0">
                 <a:solidFill>
-                  <a:srgbClr val="6B6860"/>
+                  <a:srgbClr val="4A6B8A"/>
                 </a:solidFill>
                 <a:latin typeface="Calibri" pitchFamily="34" charset="0"/>
                 <a:ea typeface="Calibri" pitchFamily="34" charset="-122"/>
@@ -7685,7 +7685,7 @@
             <a:r>
               <a:rPr lang="en-US" sz="1000" dirty="0">
                 <a:solidFill>
-                  <a:srgbClr val="6B6860"/>
+                  <a:srgbClr val="4A6B8A"/>
                 </a:solidFill>
                 <a:latin typeface="Calibri" pitchFamily="34" charset="0"/>
                 <a:ea typeface="Calibri" pitchFamily="34" charset="-122"/>
@@ -7711,7 +7711,7 @@
     <p:bg>
       <p:bgPr>
         <a:solidFill>
-          <a:srgbClr val="12161A"/>
+          <a:srgbClr val="68ACE5"/>
         </a:solidFill>
       </p:bgPr>
     </p:bg>
@@ -7759,7 +7759,7 @@
             <a:r>
               <a:rPr lang="en-US" sz="2700" i="1" dirty="0">
                 <a:solidFill>
-                  <a:srgbClr val="E8E4DB"/>
+                  <a:srgbClr val="002D72"/>
                 </a:solidFill>
                 <a:latin typeface="Georgia" pitchFamily="34" charset="0"/>
                 <a:ea typeface="Georgia" pitchFamily="34" charset="-122"/>
@@ -7788,7 +7788,7 @@
           <a:noFill/>
           <a:ln w="25400">
             <a:solidFill>
-              <a:srgbClr val="A3690C"/>
+              <a:srgbClr val="F1C400"/>
             </a:solidFill>
             <a:prstDash val="solid"/>
           </a:ln>
@@ -7821,7 +7821,7 @@
             <a:r>
               <a:rPr lang="en-US" sz="1600" b="1" dirty="0">
                 <a:solidFill>
-                  <a:srgbClr val="A3690C"/>
+                  <a:srgbClr val="002D72"/>
                 </a:solidFill>
                 <a:latin typeface="Calibri" pitchFamily="34" charset="0"/>
                 <a:ea typeface="Calibri" pitchFamily="34" charset="-122"/>
@@ -7863,7 +7863,7 @@
             <a:r>
               <a:rPr lang="en-US" sz="1300" dirty="0">
                 <a:solidFill>
-                  <a:srgbClr val="9B968C"/>
+                  <a:srgbClr val="002D72"/>
                 </a:solidFill>
                 <a:latin typeface="Calibri" pitchFamily="34" charset="0"/>
                 <a:ea typeface="Calibri" pitchFamily="34" charset="-122"/>
@@ -7883,7 +7883,7 @@
             <a:r>
               <a:rPr lang="en-US" sz="1300" dirty="0">
                 <a:solidFill>
-                  <a:srgbClr val="9B968C"/>
+                  <a:srgbClr val="002D72"/>
                 </a:solidFill>
                 <a:latin typeface="Calibri" pitchFamily="34" charset="0"/>
                 <a:ea typeface="Calibri" pitchFamily="34" charset="-122"/>
@@ -7922,7 +7922,7 @@
             <a:r>
               <a:rPr lang="en-US" sz="1000" dirty="0">
                 <a:solidFill>
-                  <a:srgbClr val="6B6860"/>
+                  <a:srgbClr val="002D72"/>
                 </a:solidFill>
                 <a:latin typeface="Calibri" pitchFamily="34" charset="0"/>
                 <a:ea typeface="Calibri" pitchFamily="34" charset="-122"/>
@@ -7936,7 +7936,7 @@
             <a:r>
               <a:rPr lang="en-US" sz="1000" u="sng" dirty="0">
                 <a:solidFill>
-                  <a:srgbClr val="6B6860"/>
+                  <a:srgbClr val="002D72"/>
                 </a:solidFill>
                 <a:latin typeface="Calibri" pitchFamily="34" charset="0"/>
                 <a:ea typeface="Calibri" pitchFamily="34" charset="-122"/>
@@ -7982,7 +7982,7 @@
             <a:r>
               <a:rPr lang="en-US" sz="1000" dirty="0">
                 <a:solidFill>
-                  <a:srgbClr val="6B6860"/>
+                  <a:srgbClr val="002D72"/>
                 </a:solidFill>
                 <a:latin typeface="Calibri" pitchFamily="34" charset="0"/>
                 <a:ea typeface="Calibri" pitchFamily="34" charset="-122"/>
@@ -8008,7 +8008,7 @@
     <p:bg>
       <p:bgPr>
         <a:solidFill>
-          <a:srgbClr val="F7F5F0"/>
+          <a:srgbClr val="F5F8FC"/>
         </a:solidFill>
       </p:bgPr>
     </p:bg>
@@ -8053,7 +8053,7 @@
             <a:r>
               <a:rPr lang="en-US" sz="1200" b="1" spc="150" kern="0" dirty="0">
                 <a:solidFill>
-                  <a:srgbClr val="A3690C"/>
+                  <a:srgbClr val="964F2E"/>
                 </a:solidFill>
                 <a:latin typeface="Calibri" pitchFamily="34" charset="0"/>
                 <a:ea typeface="Calibri" pitchFamily="34" charset="-122"/>
@@ -8092,7 +8092,7 @@
             <a:r>
               <a:rPr lang="en-US" sz="3000" b="1" dirty="0">
                 <a:solidFill>
-                  <a:srgbClr val="201D18"/>
+                  <a:srgbClr val="002D72"/>
                 </a:solidFill>
                 <a:latin typeface="Georgia" pitchFamily="34" charset="0"/>
                 <a:ea typeface="Georgia" pitchFamily="34" charset="-122"/>
@@ -8123,7 +8123,7 @@
           </a:solidFill>
           <a:ln w="12700">
             <a:solidFill>
-              <a:srgbClr val="E2DDD2"/>
+              <a:srgbClr val="D6E4F2"/>
             </a:solidFill>
             <a:prstDash val="solid"/>
           </a:ln>
@@ -8159,7 +8159,7 @@
             <a:r>
               <a:rPr lang="en-US" sz="1500" b="1" dirty="0">
                 <a:solidFill>
-                  <a:srgbClr val="0F6E67"/>
+                  <a:srgbClr val="002D72"/>
                 </a:solidFill>
                 <a:latin typeface="Georgia" pitchFamily="34" charset="0"/>
                 <a:ea typeface="Georgia" pitchFamily="34" charset="-122"/>
@@ -8201,7 +8201,7 @@
             <a:r>
               <a:rPr lang="en-US" sz="1250" dirty="0">
                 <a:solidFill>
-                  <a:srgbClr val="201D18"/>
+                  <a:srgbClr val="002D72"/>
                 </a:solidFill>
                 <a:latin typeface="Calibri" pitchFamily="34" charset="0"/>
                 <a:ea typeface="Calibri" pitchFamily="34" charset="-122"/>
@@ -8232,7 +8232,7 @@
           </a:solidFill>
           <a:ln w="12700">
             <a:solidFill>
-              <a:srgbClr val="E2DDD2"/>
+              <a:srgbClr val="D6E4F2"/>
             </a:solidFill>
             <a:prstDash val="solid"/>
           </a:ln>
@@ -8268,7 +8268,7 @@
             <a:r>
               <a:rPr lang="en-US" sz="1500" b="1" dirty="0">
                 <a:solidFill>
-                  <a:srgbClr val="0F6E67"/>
+                  <a:srgbClr val="002D72"/>
                 </a:solidFill>
                 <a:latin typeface="Georgia" pitchFamily="34" charset="0"/>
                 <a:ea typeface="Georgia" pitchFamily="34" charset="-122"/>
@@ -8310,7 +8310,7 @@
             <a:r>
               <a:rPr lang="en-US" sz="1250" dirty="0">
                 <a:solidFill>
-                  <a:srgbClr val="201D18"/>
+                  <a:srgbClr val="002D72"/>
                 </a:solidFill>
                 <a:latin typeface="Calibri" pitchFamily="34" charset="0"/>
                 <a:ea typeface="Calibri" pitchFamily="34" charset="-122"/>
@@ -8341,7 +8341,7 @@
           </a:solidFill>
           <a:ln w="12700">
             <a:solidFill>
-              <a:srgbClr val="E2DDD2"/>
+              <a:srgbClr val="D6E4F2"/>
             </a:solidFill>
             <a:prstDash val="solid"/>
           </a:ln>
@@ -8377,7 +8377,7 @@
             <a:r>
               <a:rPr lang="en-US" sz="1500" b="1" dirty="0">
                 <a:solidFill>
-                  <a:srgbClr val="0F6E67"/>
+                  <a:srgbClr val="002D72"/>
                 </a:solidFill>
                 <a:latin typeface="Georgia" pitchFamily="34" charset="0"/>
                 <a:ea typeface="Georgia" pitchFamily="34" charset="-122"/>
@@ -8419,7 +8419,7 @@
             <a:r>
               <a:rPr lang="en-US" sz="1250" dirty="0">
                 <a:solidFill>
-                  <a:srgbClr val="201D18"/>
+                  <a:srgbClr val="002D72"/>
                 </a:solidFill>
                 <a:latin typeface="Calibri" pitchFamily="34" charset="0"/>
                 <a:ea typeface="Calibri" pitchFamily="34" charset="-122"/>
@@ -8458,7 +8458,7 @@
             <a:r>
               <a:rPr lang="en-US" sz="1000" dirty="0">
                 <a:solidFill>
-                  <a:srgbClr val="6B6860"/>
+                  <a:srgbClr val="4A6B8A"/>
                 </a:solidFill>
                 <a:latin typeface="Calibri" pitchFamily="34" charset="0"/>
                 <a:ea typeface="Calibri" pitchFamily="34" charset="-122"/>
@@ -8472,7 +8472,7 @@
             <a:r>
               <a:rPr lang="en-US" sz="1000" u="sng" dirty="0">
                 <a:solidFill>
-                  <a:srgbClr val="6B6860"/>
+                  <a:srgbClr val="4A6B8A"/>
                 </a:solidFill>
                 <a:latin typeface="Calibri" pitchFamily="34" charset="0"/>
                 <a:ea typeface="Calibri" pitchFamily="34" charset="-122"/>
@@ -8493,7 +8493,7 @@
             <a:r>
               <a:rPr lang="en-US" sz="1000" dirty="0">
                 <a:solidFill>
-                  <a:srgbClr val="6B6860"/>
+                  <a:srgbClr val="4A6B8A"/>
                 </a:solidFill>
                 <a:latin typeface="Calibri" pitchFamily="34" charset="0"/>
                 <a:ea typeface="Calibri" pitchFamily="34" charset="-122"/>
@@ -8507,7 +8507,7 @@
             <a:r>
               <a:rPr lang="en-US" sz="1000" u="sng" dirty="0">
                 <a:solidFill>
-                  <a:srgbClr val="6B6860"/>
+                  <a:srgbClr val="4A6B8A"/>
                 </a:solidFill>
                 <a:latin typeface="Calibri" pitchFamily="34" charset="0"/>
                 <a:ea typeface="Calibri" pitchFamily="34" charset="-122"/>
@@ -8553,7 +8553,7 @@
             <a:r>
               <a:rPr lang="en-US" sz="1000" dirty="0">
                 <a:solidFill>
-                  <a:srgbClr val="6B6860"/>
+                  <a:srgbClr val="4A6B8A"/>
                 </a:solidFill>
                 <a:latin typeface="Calibri" pitchFamily="34" charset="0"/>
                 <a:ea typeface="Calibri" pitchFamily="34" charset="-122"/>
@@ -8579,7 +8579,7 @@
     <p:bg>
       <p:bgPr>
         <a:solidFill>
-          <a:srgbClr val="12161A"/>
+          <a:srgbClr val="68ACE5"/>
         </a:solidFill>
       </p:bgPr>
     </p:bg>
@@ -8624,7 +8624,7 @@
             <a:r>
               <a:rPr lang="en-US" sz="1400" b="1" spc="200" kern="0" dirty="0">
                 <a:solidFill>
-                  <a:srgbClr val="A3690C"/>
+                  <a:srgbClr val="002D72"/>
                 </a:solidFill>
                 <a:latin typeface="Calibri" pitchFamily="34" charset="0"/>
                 <a:ea typeface="Calibri" pitchFamily="34" charset="-122"/>
@@ -8663,7 +8663,7 @@
             <a:r>
               <a:rPr lang="en-US" sz="11000" b="1" dirty="0">
                 <a:solidFill>
-                  <a:srgbClr val="23282E"/>
+                  <a:srgbClr val="8FC4EE"/>
                 </a:solidFill>
                 <a:latin typeface="Georgia" pitchFamily="34" charset="0"/>
                 <a:ea typeface="Georgia" pitchFamily="34" charset="-122"/>
@@ -8705,7 +8705,7 @@
             <a:r>
               <a:rPr lang="en-US" sz="3800" b="1" dirty="0">
                 <a:solidFill>
-                  <a:srgbClr val="E8E4DB"/>
+                  <a:srgbClr val="002D72"/>
                 </a:solidFill>
                 <a:latin typeface="Georgia" pitchFamily="34" charset="0"/>
                 <a:ea typeface="Georgia" pitchFamily="34" charset="-122"/>
@@ -8747,7 +8747,7 @@
             <a:r>
               <a:rPr lang="en-US" sz="1500" i="1" dirty="0">
                 <a:solidFill>
-                  <a:srgbClr val="9B968C"/>
+                  <a:srgbClr val="002D72"/>
                 </a:solidFill>
                 <a:latin typeface="Calibri" pitchFamily="34" charset="0"/>
                 <a:ea typeface="Calibri" pitchFamily="34" charset="-122"/>
@@ -8773,7 +8773,7 @@
     <p:bg>
       <p:bgPr>
         <a:solidFill>
-          <a:srgbClr val="F7F5F0"/>
+          <a:srgbClr val="F5F8FC"/>
         </a:solidFill>
       </p:bgPr>
     </p:bg>
@@ -8818,7 +8818,7 @@
             <a:r>
               <a:rPr lang="en-US" sz="1200" b="1" spc="150" kern="0" dirty="0">
                 <a:solidFill>
-                  <a:srgbClr val="A3690C"/>
+                  <a:srgbClr val="964F2E"/>
                 </a:solidFill>
                 <a:latin typeface="Calibri" pitchFamily="34" charset="0"/>
                 <a:ea typeface="Calibri" pitchFamily="34" charset="-122"/>
@@ -8857,7 +8857,7 @@
             <a:r>
               <a:rPr lang="en-US" sz="3000" b="1" dirty="0">
                 <a:solidFill>
-                  <a:srgbClr val="201D18"/>
+                  <a:srgbClr val="002D72"/>
                 </a:solidFill>
                 <a:latin typeface="Georgia" pitchFamily="34" charset="0"/>
                 <a:ea typeface="Georgia" pitchFamily="34" charset="-122"/>
@@ -8903,7 +8903,7 @@
             <a:r>
               <a:rPr lang="en-US" sz="1650" dirty="0">
                 <a:solidFill>
-                  <a:srgbClr val="201D18"/>
+                  <a:srgbClr val="002D72"/>
                 </a:solidFill>
                 <a:latin typeface="Calibri" pitchFamily="34" charset="0"/>
                 <a:ea typeface="Calibri" pitchFamily="34" charset="-122"/>
@@ -8927,7 +8927,7 @@
             <a:r>
               <a:rPr lang="en-US" sz="1650" dirty="0">
                 <a:solidFill>
-                  <a:srgbClr val="201D18"/>
+                  <a:srgbClr val="002D72"/>
                 </a:solidFill>
                 <a:latin typeface="Calibri" pitchFamily="34" charset="0"/>
                 <a:ea typeface="Calibri" pitchFamily="34" charset="-122"/>
@@ -8951,7 +8951,7 @@
             <a:r>
               <a:rPr lang="en-US" sz="1650" dirty="0">
                 <a:solidFill>
-                  <a:srgbClr val="201D18"/>
+                  <a:srgbClr val="002D72"/>
                 </a:solidFill>
                 <a:latin typeface="Calibri" pitchFamily="34" charset="0"/>
                 <a:ea typeface="Calibri" pitchFamily="34" charset="-122"/>
@@ -8975,7 +8975,7 @@
             <a:r>
               <a:rPr lang="en-US" sz="1650" dirty="0">
                 <a:solidFill>
-                  <a:srgbClr val="201D18"/>
+                  <a:srgbClr val="002D72"/>
                 </a:solidFill>
                 <a:latin typeface="Calibri" pitchFamily="34" charset="0"/>
                 <a:ea typeface="Calibri" pitchFamily="34" charset="-122"/>
@@ -9014,7 +9014,7 @@
             <a:r>
               <a:rPr lang="en-US" sz="1000" dirty="0">
                 <a:solidFill>
-                  <a:srgbClr val="6B6860"/>
+                  <a:srgbClr val="4A6B8A"/>
                 </a:solidFill>
                 <a:latin typeface="Calibri" pitchFamily="34" charset="0"/>
                 <a:ea typeface="Calibri" pitchFamily="34" charset="-122"/>
@@ -9028,7 +9028,7 @@
             <a:r>
               <a:rPr lang="en-US" sz="1000" u="sng" dirty="0">
                 <a:solidFill>
-                  <a:srgbClr val="6B6860"/>
+                  <a:srgbClr val="4A6B8A"/>
                 </a:solidFill>
                 <a:latin typeface="Calibri" pitchFamily="34" charset="0"/>
                 <a:ea typeface="Calibri" pitchFamily="34" charset="-122"/>
@@ -9049,7 +9049,7 @@
             <a:r>
               <a:rPr lang="en-US" sz="1000" dirty="0">
                 <a:solidFill>
-                  <a:srgbClr val="6B6860"/>
+                  <a:srgbClr val="4A6B8A"/>
                 </a:solidFill>
                 <a:latin typeface="Calibri" pitchFamily="34" charset="0"/>
                 <a:ea typeface="Calibri" pitchFamily="34" charset="-122"/>
@@ -9063,7 +9063,7 @@
             <a:r>
               <a:rPr lang="en-US" sz="1000" u="sng" dirty="0">
                 <a:solidFill>
-                  <a:srgbClr val="6B6860"/>
+                  <a:srgbClr val="4A6B8A"/>
                 </a:solidFill>
                 <a:latin typeface="Calibri" pitchFamily="34" charset="0"/>
                 <a:ea typeface="Calibri" pitchFamily="34" charset="-122"/>
@@ -9109,7 +9109,7 @@
             <a:r>
               <a:rPr lang="en-US" sz="1000" dirty="0">
                 <a:solidFill>
-                  <a:srgbClr val="6B6860"/>
+                  <a:srgbClr val="4A6B8A"/>
                 </a:solidFill>
                 <a:latin typeface="Calibri" pitchFamily="34" charset="0"/>
                 <a:ea typeface="Calibri" pitchFamily="34" charset="-122"/>
@@ -9135,7 +9135,7 @@
     <p:bg>
       <p:bgPr>
         <a:solidFill>
-          <a:srgbClr val="F7F5F0"/>
+          <a:srgbClr val="F5F8FC"/>
         </a:solidFill>
       </p:bgPr>
     </p:bg>
@@ -9180,7 +9180,7 @@
             <a:r>
               <a:rPr lang="en-US" sz="1200" b="1" spc="150" kern="0" dirty="0">
                 <a:solidFill>
-                  <a:srgbClr val="A3690C"/>
+                  <a:srgbClr val="964F2E"/>
                 </a:solidFill>
                 <a:latin typeface="Calibri" pitchFamily="34" charset="0"/>
                 <a:ea typeface="Calibri" pitchFamily="34" charset="-122"/>
@@ -9222,7 +9222,7 @@
             <a:r>
               <a:rPr lang="en-US" sz="3200" b="1" i="1" dirty="0">
                 <a:solidFill>
-                  <a:srgbClr val="201D18"/>
+                  <a:srgbClr val="002D72"/>
                 </a:solidFill>
                 <a:latin typeface="Georgia" pitchFamily="34" charset="0"/>
                 <a:ea typeface="Georgia" pitchFamily="34" charset="-122"/>
@@ -9264,7 +9264,7 @@
             <a:r>
               <a:rPr lang="en-US" sz="1600" dirty="0">
                 <a:solidFill>
-                  <a:srgbClr val="201D18"/>
+                  <a:srgbClr val="002D72"/>
                 </a:solidFill>
                 <a:latin typeface="Calibri" pitchFamily="34" charset="0"/>
                 <a:ea typeface="Calibri" pitchFamily="34" charset="-122"/>
@@ -9293,7 +9293,7 @@
           <a:noFill/>
           <a:ln w="25400">
             <a:solidFill>
-              <a:srgbClr val="A3690C"/>
+              <a:srgbClr val="F1C400"/>
             </a:solidFill>
             <a:prstDash val="solid"/>
           </a:ln>
@@ -9326,7 +9326,7 @@
             <a:r>
               <a:rPr lang="en-US" sz="1400" b="1" dirty="0">
                 <a:solidFill>
-                  <a:srgbClr val="A3690C"/>
+                  <a:srgbClr val="964F2E"/>
                 </a:solidFill>
                 <a:latin typeface="Calibri" pitchFamily="34" charset="0"/>
                 <a:ea typeface="Calibri" pitchFamily="34" charset="-122"/>
@@ -9365,7 +9365,7 @@
             <a:r>
               <a:rPr lang="en-US" sz="1000" dirty="0">
                 <a:solidFill>
-                  <a:srgbClr val="6B6860"/>
+                  <a:srgbClr val="4A6B8A"/>
                 </a:solidFill>
                 <a:latin typeface="Calibri" pitchFamily="34" charset="0"/>
                 <a:ea typeface="Calibri" pitchFamily="34" charset="-122"/>
@@ -9379,7 +9379,7 @@
             <a:r>
               <a:rPr lang="en-US" sz="1000" u="sng" dirty="0">
                 <a:solidFill>
-                  <a:srgbClr val="6B6860"/>
+                  <a:srgbClr val="4A6B8A"/>
                 </a:solidFill>
                 <a:latin typeface="Calibri" pitchFamily="34" charset="0"/>
                 <a:ea typeface="Calibri" pitchFamily="34" charset="-122"/>
@@ -9425,7 +9425,7 @@
             <a:r>
               <a:rPr lang="en-US" sz="1000" dirty="0">
                 <a:solidFill>
-                  <a:srgbClr val="6B6860"/>
+                  <a:srgbClr val="4A6B8A"/>
                 </a:solidFill>
                 <a:latin typeface="Calibri" pitchFamily="34" charset="0"/>
                 <a:ea typeface="Calibri" pitchFamily="34" charset="-122"/>
@@ -9451,7 +9451,7 @@
     <p:bg>
       <p:bgPr>
         <a:solidFill>
-          <a:srgbClr val="F7F5F0"/>
+          <a:srgbClr val="F5F8FC"/>
         </a:solidFill>
       </p:bgPr>
     </p:bg>
@@ -9496,7 +9496,7 @@
             <a:r>
               <a:rPr lang="en-US" sz="1200" b="1" spc="150" kern="0" dirty="0">
                 <a:solidFill>
-                  <a:srgbClr val="A3690C"/>
+                  <a:srgbClr val="964F2E"/>
                 </a:solidFill>
                 <a:latin typeface="Calibri" pitchFamily="34" charset="0"/>
                 <a:ea typeface="Calibri" pitchFamily="34" charset="-122"/>
@@ -9535,7 +9535,7 @@
             <a:r>
               <a:rPr lang="en-US" sz="3000" b="1" dirty="0">
                 <a:solidFill>
-                  <a:srgbClr val="201D18"/>
+                  <a:srgbClr val="002D72"/>
                 </a:solidFill>
                 <a:latin typeface="Georgia" pitchFamily="34" charset="0"/>
                 <a:ea typeface="Georgia" pitchFamily="34" charset="-122"/>
@@ -9581,7 +9581,7 @@
             <a:r>
               <a:rPr lang="en-US" sz="1550" dirty="0">
                 <a:solidFill>
-                  <a:srgbClr val="201D18"/>
+                  <a:srgbClr val="002D72"/>
                 </a:solidFill>
                 <a:latin typeface="Calibri" pitchFamily="34" charset="0"/>
                 <a:ea typeface="Calibri" pitchFamily="34" charset="-122"/>
@@ -9605,7 +9605,7 @@
             <a:r>
               <a:rPr lang="en-US" sz="1550" dirty="0">
                 <a:solidFill>
-                  <a:srgbClr val="201D18"/>
+                  <a:srgbClr val="002D72"/>
                 </a:solidFill>
                 <a:latin typeface="Calibri" pitchFamily="34" charset="0"/>
                 <a:ea typeface="Calibri" pitchFamily="34" charset="-122"/>
@@ -9629,7 +9629,7 @@
             <a:r>
               <a:rPr lang="en-US" sz="1550" dirty="0">
                 <a:solidFill>
-                  <a:srgbClr val="201D18"/>
+                  <a:srgbClr val="002D72"/>
                 </a:solidFill>
                 <a:latin typeface="Calibri" pitchFamily="34" charset="0"/>
                 <a:ea typeface="Calibri" pitchFamily="34" charset="-122"/>
@@ -9653,7 +9653,7 @@
             <a:r>
               <a:rPr lang="en-US" sz="1550" dirty="0">
                 <a:solidFill>
-                  <a:srgbClr val="201D18"/>
+                  <a:srgbClr val="002D72"/>
                 </a:solidFill>
                 <a:latin typeface="Calibri" pitchFamily="34" charset="0"/>
                 <a:ea typeface="Calibri" pitchFamily="34" charset="-122"/>
@@ -9680,7 +9680,7 @@
             <a:avLst/>
           </a:prstGeom>
           <a:solidFill>
-            <a:srgbClr val="0F6E67"/>
+            <a:srgbClr val="002D72"/>
           </a:solidFill>
           <a:ln/>
         </p:spPr>
@@ -9754,7 +9754,7 @@
             <a:r>
               <a:rPr lang="en-US" sz="1200" b="1" dirty="0">
                 <a:solidFill>
-                  <a:srgbClr val="DDEFEC"/>
+                  <a:srgbClr val="DCEBFA"/>
                 </a:solidFill>
                 <a:latin typeface="Calibri" pitchFamily="34" charset="0"/>
                 <a:ea typeface="Calibri" pitchFamily="34" charset="-122"/>
@@ -9793,7 +9793,7 @@
             <a:r>
               <a:rPr lang="en-US" sz="1000" dirty="0">
                 <a:solidFill>
-                  <a:srgbClr val="6B6860"/>
+                  <a:srgbClr val="4A6B8A"/>
                 </a:solidFill>
                 <a:latin typeface="Calibri" pitchFamily="34" charset="0"/>
                 <a:ea typeface="Calibri" pitchFamily="34" charset="-122"/>
@@ -9807,7 +9807,7 @@
             <a:r>
               <a:rPr lang="en-US" sz="1000" u="sng" dirty="0">
                 <a:solidFill>
-                  <a:srgbClr val="6B6860"/>
+                  <a:srgbClr val="4A6B8A"/>
                 </a:solidFill>
                 <a:latin typeface="Calibri" pitchFamily="34" charset="0"/>
                 <a:ea typeface="Calibri" pitchFamily="34" charset="-122"/>
@@ -9853,7 +9853,7 @@
             <a:r>
               <a:rPr lang="en-US" sz="1000" dirty="0">
                 <a:solidFill>
-                  <a:srgbClr val="6B6860"/>
+                  <a:srgbClr val="4A6B8A"/>
                 </a:solidFill>
                 <a:latin typeface="Calibri" pitchFamily="34" charset="0"/>
                 <a:ea typeface="Calibri" pitchFamily="34" charset="-122"/>
@@ -9879,7 +9879,7 @@
     <p:bg>
       <p:bgPr>
         <a:solidFill>
-          <a:srgbClr val="12161A"/>
+          <a:srgbClr val="68ACE5"/>
         </a:solidFill>
       </p:bgPr>
     </p:bg>
@@ -9924,7 +9924,7 @@
             <a:r>
               <a:rPr lang="en-US" sz="1400" b="1" spc="200" kern="0" dirty="0">
                 <a:solidFill>
-                  <a:srgbClr val="A3690C"/>
+                  <a:srgbClr val="002D72"/>
                 </a:solidFill>
                 <a:latin typeface="Calibri" pitchFamily="34" charset="0"/>
                 <a:ea typeface="Calibri" pitchFamily="34" charset="-122"/>
@@ -9963,7 +9963,7 @@
             <a:r>
               <a:rPr lang="en-US" sz="11000" b="1" dirty="0">
                 <a:solidFill>
-                  <a:srgbClr val="23282E"/>
+                  <a:srgbClr val="8FC4EE"/>
                 </a:solidFill>
                 <a:latin typeface="Georgia" pitchFamily="34" charset="0"/>
                 <a:ea typeface="Georgia" pitchFamily="34" charset="-122"/>
@@ -10005,7 +10005,7 @@
             <a:r>
               <a:rPr lang="en-US" sz="3800" b="1" dirty="0">
                 <a:solidFill>
-                  <a:srgbClr val="E8E4DB"/>
+                  <a:srgbClr val="002D72"/>
                 </a:solidFill>
                 <a:latin typeface="Georgia" pitchFamily="34" charset="0"/>
                 <a:ea typeface="Georgia" pitchFamily="34" charset="-122"/>
@@ -10047,7 +10047,7 @@
             <a:r>
               <a:rPr lang="en-US" sz="1500" i="1" dirty="0">
                 <a:solidFill>
-                  <a:srgbClr val="9B968C"/>
+                  <a:srgbClr val="002D72"/>
                 </a:solidFill>
                 <a:latin typeface="Calibri" pitchFamily="34" charset="0"/>
                 <a:ea typeface="Calibri" pitchFamily="34" charset="-122"/>
@@ -10073,7 +10073,7 @@
     <p:bg>
       <p:bgPr>
         <a:solidFill>
-          <a:srgbClr val="F7F5F0"/>
+          <a:srgbClr val="F5F8FC"/>
         </a:solidFill>
       </p:bgPr>
     </p:bg>
@@ -10118,7 +10118,7 @@
             <a:r>
               <a:rPr lang="en-US" sz="1200" b="1" spc="150" kern="0" dirty="0">
                 <a:solidFill>
-                  <a:srgbClr val="A3690C"/>
+                  <a:srgbClr val="964F2E"/>
                 </a:solidFill>
                 <a:latin typeface="Calibri" pitchFamily="34" charset="0"/>
                 <a:ea typeface="Calibri" pitchFamily="34" charset="-122"/>
@@ -10157,7 +10157,7 @@
             <a:r>
               <a:rPr lang="en-US" sz="3000" b="1" dirty="0">
                 <a:solidFill>
-                  <a:srgbClr val="201D18"/>
+                  <a:srgbClr val="002D72"/>
                 </a:solidFill>
                 <a:latin typeface="Georgia" pitchFamily="34" charset="0"/>
                 <a:ea typeface="Georgia" pitchFamily="34" charset="-122"/>
@@ -10188,7 +10188,7 @@
           </a:solidFill>
           <a:ln w="12700">
             <a:solidFill>
-              <a:srgbClr val="E2DDD2"/>
+              <a:srgbClr val="D6E4F2"/>
             </a:solidFill>
             <a:prstDash val="solid"/>
           </a:ln>
@@ -10221,7 +10221,7 @@
             <a:r>
               <a:rPr lang="en-US" sz="2200" b="1" dirty="0">
                 <a:solidFill>
-                  <a:srgbClr val="201D18"/>
+                  <a:srgbClr val="002D72"/>
                 </a:solidFill>
                 <a:latin typeface="Georgia" pitchFamily="34" charset="0"/>
                 <a:ea typeface="Georgia" pitchFamily="34" charset="-122"/>
@@ -10260,7 +10260,7 @@
             <a:r>
               <a:rPr lang="en-US" sz="1100" b="1" spc="100" kern="0" dirty="0">
                 <a:solidFill>
-                  <a:srgbClr val="6B6860"/>
+                  <a:srgbClr val="4A6B8A"/>
                 </a:solidFill>
                 <a:latin typeface="Calibri" pitchFamily="34" charset="0"/>
                 <a:ea typeface="Calibri" pitchFamily="34" charset="-122"/>
@@ -10302,7 +10302,7 @@
             <a:r>
               <a:rPr lang="en-US" sz="1400" dirty="0">
                 <a:solidFill>
-                  <a:srgbClr val="201D18"/>
+                  <a:srgbClr val="002D72"/>
                 </a:solidFill>
                 <a:latin typeface="Calibri" pitchFamily="34" charset="0"/>
                 <a:ea typeface="Calibri" pitchFamily="34" charset="-122"/>
@@ -10333,7 +10333,7 @@
           </a:solidFill>
           <a:ln w="12700">
             <a:solidFill>
-              <a:srgbClr val="E2DDD2"/>
+              <a:srgbClr val="D6E4F2"/>
             </a:solidFill>
             <a:prstDash val="solid"/>
           </a:ln>
@@ -10366,7 +10366,7 @@
             <a:r>
               <a:rPr lang="en-US" sz="2200" b="1" dirty="0">
                 <a:solidFill>
-                  <a:srgbClr val="201D18"/>
+                  <a:srgbClr val="002D72"/>
                 </a:solidFill>
                 <a:latin typeface="Georgia" pitchFamily="34" charset="0"/>
                 <a:ea typeface="Georgia" pitchFamily="34" charset="-122"/>
@@ -10405,7 +10405,7 @@
             <a:r>
               <a:rPr lang="en-US" sz="1100" b="1" spc="100" kern="0" dirty="0">
                 <a:solidFill>
-                  <a:srgbClr val="A3690C"/>
+                  <a:srgbClr val="964F2E"/>
                 </a:solidFill>
                 <a:latin typeface="Calibri" pitchFamily="34" charset="0"/>
                 <a:ea typeface="Calibri" pitchFamily="34" charset="-122"/>
@@ -10447,7 +10447,7 @@
             <a:r>
               <a:rPr lang="en-US" sz="1400" dirty="0">
                 <a:solidFill>
-                  <a:srgbClr val="201D18"/>
+                  <a:srgbClr val="002D72"/>
                 </a:solidFill>
                 <a:latin typeface="Calibri" pitchFamily="34" charset="0"/>
                 <a:ea typeface="Calibri" pitchFamily="34" charset="-122"/>
@@ -10486,7 +10486,7 @@
             <a:r>
               <a:rPr lang="en-US" sz="1000" dirty="0">
                 <a:solidFill>
-                  <a:srgbClr val="6B6860"/>
+                  <a:srgbClr val="4A6B8A"/>
                 </a:solidFill>
                 <a:latin typeface="Calibri" pitchFamily="34" charset="0"/>
                 <a:ea typeface="Calibri" pitchFamily="34" charset="-122"/>
@@ -10500,7 +10500,7 @@
             <a:r>
               <a:rPr lang="en-US" sz="1000" u="sng" dirty="0">
                 <a:solidFill>
-                  <a:srgbClr val="6B6860"/>
+                  <a:srgbClr val="4A6B8A"/>
                 </a:solidFill>
                 <a:latin typeface="Calibri" pitchFamily="34" charset="0"/>
                 <a:ea typeface="Calibri" pitchFamily="34" charset="-122"/>
@@ -10521,7 +10521,7 @@
             <a:r>
               <a:rPr lang="en-US" sz="1000" dirty="0">
                 <a:solidFill>
-                  <a:srgbClr val="6B6860"/>
+                  <a:srgbClr val="4A6B8A"/>
                 </a:solidFill>
                 <a:latin typeface="Calibri" pitchFamily="34" charset="0"/>
                 <a:ea typeface="Calibri" pitchFamily="34" charset="-122"/>
@@ -10535,7 +10535,7 @@
             <a:r>
               <a:rPr lang="en-US" sz="1000" u="sng" dirty="0">
                 <a:solidFill>
-                  <a:srgbClr val="6B6860"/>
+                  <a:srgbClr val="4A6B8A"/>
                 </a:solidFill>
                 <a:latin typeface="Calibri" pitchFamily="34" charset="0"/>
                 <a:ea typeface="Calibri" pitchFamily="34" charset="-122"/>
@@ -10581,7 +10581,7 @@
             <a:r>
               <a:rPr lang="en-US" sz="1000" dirty="0">
                 <a:solidFill>
-                  <a:srgbClr val="6B6860"/>
+                  <a:srgbClr val="4A6B8A"/>
                 </a:solidFill>
                 <a:latin typeface="Calibri" pitchFamily="34" charset="0"/>
                 <a:ea typeface="Calibri" pitchFamily="34" charset="-122"/>
@@ -10607,7 +10607,7 @@
     <p:bg>
       <p:bgPr>
         <a:solidFill>
-          <a:srgbClr val="F7F5F0"/>
+          <a:srgbClr val="F5F8FC"/>
         </a:solidFill>
       </p:bgPr>
     </p:bg>
@@ -10652,7 +10652,7 @@
             <a:r>
               <a:rPr lang="en-US" sz="1200" b="1" spc="150" kern="0" dirty="0">
                 <a:solidFill>
-                  <a:srgbClr val="A3690C"/>
+                  <a:srgbClr val="964F2E"/>
                 </a:solidFill>
                 <a:latin typeface="Calibri" pitchFamily="34" charset="0"/>
                 <a:ea typeface="Calibri" pitchFamily="34" charset="-122"/>
@@ -10691,7 +10691,7 @@
             <a:r>
               <a:rPr lang="en-US" sz="3000" b="1" dirty="0">
                 <a:solidFill>
-                  <a:srgbClr val="201D18"/>
+                  <a:srgbClr val="002D72"/>
                 </a:solidFill>
                 <a:latin typeface="Georgia" pitchFamily="34" charset="0"/>
                 <a:ea typeface="Georgia" pitchFamily="34" charset="-122"/>
@@ -10730,7 +10730,7 @@
             <a:r>
               <a:rPr lang="en-US" sz="1600" b="1" dirty="0">
                 <a:solidFill>
-                  <a:srgbClr val="201D18"/>
+                  <a:srgbClr val="002D72"/>
                 </a:solidFill>
                 <a:latin typeface="Calibri" pitchFamily="34" charset="0"/>
                 <a:ea typeface="Calibri" pitchFamily="34" charset="-122"/>
@@ -10769,7 +10769,7 @@
             <a:r>
               <a:rPr lang="en-US" sz="1250" dirty="0">
                 <a:solidFill>
-                  <a:srgbClr val="6B6860"/>
+                  <a:srgbClr val="4A6B8A"/>
                 </a:solidFill>
                 <a:latin typeface="Calibri" pitchFamily="34" charset="0"/>
                 <a:ea typeface="Calibri" pitchFamily="34" charset="-122"/>
@@ -10808,7 +10808,7 @@
             <a:r>
               <a:rPr lang="en-US" sz="1600" b="1" dirty="0">
                 <a:solidFill>
-                  <a:srgbClr val="201D18"/>
+                  <a:srgbClr val="002D72"/>
                 </a:solidFill>
                 <a:latin typeface="Calibri" pitchFamily="34" charset="0"/>
                 <a:ea typeface="Calibri" pitchFamily="34" charset="-122"/>
@@ -10847,7 +10847,7 @@
             <a:r>
               <a:rPr lang="en-US" sz="1250" dirty="0">
                 <a:solidFill>
-                  <a:srgbClr val="6B6860"/>
+                  <a:srgbClr val="4A6B8A"/>
                 </a:solidFill>
                 <a:latin typeface="Calibri" pitchFamily="34" charset="0"/>
                 <a:ea typeface="Calibri" pitchFamily="34" charset="-122"/>
@@ -10886,7 +10886,7 @@
             <a:r>
               <a:rPr lang="en-US" sz="1600" b="1" dirty="0">
                 <a:solidFill>
-                  <a:srgbClr val="201D18"/>
+                  <a:srgbClr val="002D72"/>
                 </a:solidFill>
                 <a:latin typeface="Calibri" pitchFamily="34" charset="0"/>
                 <a:ea typeface="Calibri" pitchFamily="34" charset="-122"/>
@@ -10925,7 +10925,7 @@
             <a:r>
               <a:rPr lang="en-US" sz="1250" dirty="0">
                 <a:solidFill>
-                  <a:srgbClr val="6B6860"/>
+                  <a:srgbClr val="4A6B8A"/>
                 </a:solidFill>
                 <a:latin typeface="Calibri" pitchFamily="34" charset="0"/>
                 <a:ea typeface="Calibri" pitchFamily="34" charset="-122"/>
@@ -10964,7 +10964,7 @@
             <a:r>
               <a:rPr lang="en-US" sz="1600" b="1" dirty="0">
                 <a:solidFill>
-                  <a:srgbClr val="201D18"/>
+                  <a:srgbClr val="002D72"/>
                 </a:solidFill>
                 <a:latin typeface="Calibri" pitchFamily="34" charset="0"/>
                 <a:ea typeface="Calibri" pitchFamily="34" charset="-122"/>
@@ -11003,7 +11003,7 @@
             <a:r>
               <a:rPr lang="en-US" sz="1250" dirty="0">
                 <a:solidFill>
-                  <a:srgbClr val="6B6860"/>
+                  <a:srgbClr val="4A6B8A"/>
                 </a:solidFill>
                 <a:latin typeface="Calibri" pitchFamily="34" charset="0"/>
                 <a:ea typeface="Calibri" pitchFamily="34" charset="-122"/>
@@ -11042,7 +11042,7 @@
             <a:r>
               <a:rPr lang="en-US" sz="1000" dirty="0">
                 <a:solidFill>
-                  <a:srgbClr val="6B6860"/>
+                  <a:srgbClr val="4A6B8A"/>
                 </a:solidFill>
                 <a:latin typeface="Calibri" pitchFamily="34" charset="0"/>
                 <a:ea typeface="Calibri" pitchFamily="34" charset="-122"/>
@@ -11056,7 +11056,7 @@
             <a:r>
               <a:rPr lang="en-US" sz="1000" u="sng" dirty="0">
                 <a:solidFill>
-                  <a:srgbClr val="6B6860"/>
+                  <a:srgbClr val="4A6B8A"/>
                 </a:solidFill>
                 <a:latin typeface="Calibri" pitchFamily="34" charset="0"/>
                 <a:ea typeface="Calibri" pitchFamily="34" charset="-122"/>
@@ -11077,7 +11077,7 @@
             <a:r>
               <a:rPr lang="en-US" sz="1000" dirty="0">
                 <a:solidFill>
-                  <a:srgbClr val="6B6860"/>
+                  <a:srgbClr val="4A6B8A"/>
                 </a:solidFill>
                 <a:latin typeface="Calibri" pitchFamily="34" charset="0"/>
                 <a:ea typeface="Calibri" pitchFamily="34" charset="-122"/>
@@ -11091,7 +11091,7 @@
             <a:r>
               <a:rPr lang="en-US" sz="1000" u="sng" dirty="0">
                 <a:solidFill>
-                  <a:srgbClr val="6B6860"/>
+                  <a:srgbClr val="4A6B8A"/>
                 </a:solidFill>
                 <a:latin typeface="Calibri" pitchFamily="34" charset="0"/>
                 <a:ea typeface="Calibri" pitchFamily="34" charset="-122"/>
@@ -11137,7 +11137,7 @@
             <a:r>
               <a:rPr lang="en-US" sz="1000" dirty="0">
                 <a:solidFill>
-                  <a:srgbClr val="6B6860"/>
+                  <a:srgbClr val="4A6B8A"/>
                 </a:solidFill>
                 <a:latin typeface="Calibri" pitchFamily="34" charset="0"/>
                 <a:ea typeface="Calibri" pitchFamily="34" charset="-122"/>
@@ -11163,7 +11163,7 @@
     <p:bg>
       <p:bgPr>
         <a:solidFill>
-          <a:srgbClr val="F7F5F0"/>
+          <a:srgbClr val="F5F8FC"/>
         </a:solidFill>
       </p:bgPr>
     </p:bg>
@@ -11208,7 +11208,7 @@
             <a:r>
               <a:rPr lang="en-US" sz="1200" b="1" spc="150" kern="0" dirty="0">
                 <a:solidFill>
-                  <a:srgbClr val="A3690C"/>
+                  <a:srgbClr val="964F2E"/>
                 </a:solidFill>
                 <a:latin typeface="Calibri" pitchFamily="34" charset="0"/>
                 <a:ea typeface="Calibri" pitchFamily="34" charset="-122"/>
@@ -11247,7 +11247,7 @@
             <a:r>
               <a:rPr lang="en-US" sz="3000" b="1" dirty="0">
                 <a:solidFill>
-                  <a:srgbClr val="201D18"/>
+                  <a:srgbClr val="002D72"/>
                 </a:solidFill>
                 <a:latin typeface="Georgia" pitchFamily="34" charset="0"/>
                 <a:ea typeface="Georgia" pitchFamily="34" charset="-122"/>
@@ -11278,7 +11278,7 @@
           </a:solidFill>
           <a:ln w="12700">
             <a:solidFill>
-              <a:srgbClr val="E2DDD2"/>
+              <a:srgbClr val="D6E4F2"/>
             </a:solidFill>
             <a:prstDash val="solid"/>
           </a:ln>
@@ -11314,7 +11314,7 @@
             <a:r>
               <a:rPr lang="en-US" sz="1550" i="1" dirty="0">
                 <a:solidFill>
-                  <a:srgbClr val="201D18"/>
+                  <a:srgbClr val="002D72"/>
                 </a:solidFill>
                 <a:latin typeface="Georgia" pitchFamily="34" charset="0"/>
                 <a:ea typeface="Georgia" pitchFamily="34" charset="-122"/>
@@ -11353,7 +11353,7 @@
             <a:r>
               <a:rPr lang="en-US" sz="1200" b="1" dirty="0">
                 <a:solidFill>
-                  <a:srgbClr val="A3690C"/>
+                  <a:srgbClr val="964F2E"/>
                 </a:solidFill>
                 <a:latin typeface="Calibri" pitchFamily="34" charset="0"/>
                 <a:ea typeface="Calibri" pitchFamily="34" charset="-122"/>
@@ -11384,7 +11384,7 @@
           </a:solidFill>
           <a:ln w="12700">
             <a:solidFill>
-              <a:srgbClr val="E2DDD2"/>
+              <a:srgbClr val="D6E4F2"/>
             </a:solidFill>
             <a:prstDash val="solid"/>
           </a:ln>
@@ -11420,7 +11420,7 @@
             <a:r>
               <a:rPr lang="en-US" sz="1550" i="1" dirty="0">
                 <a:solidFill>
-                  <a:srgbClr val="201D18"/>
+                  <a:srgbClr val="002D72"/>
                 </a:solidFill>
                 <a:latin typeface="Georgia" pitchFamily="34" charset="0"/>
                 <a:ea typeface="Georgia" pitchFamily="34" charset="-122"/>
@@ -11459,7 +11459,7 @@
             <a:r>
               <a:rPr lang="en-US" sz="1200" b="1" dirty="0">
                 <a:solidFill>
-                  <a:srgbClr val="A3690C"/>
+                  <a:srgbClr val="964F2E"/>
                 </a:solidFill>
                 <a:latin typeface="Calibri" pitchFamily="34" charset="0"/>
                 <a:ea typeface="Calibri" pitchFamily="34" charset="-122"/>
@@ -11498,7 +11498,7 @@
             <a:r>
               <a:rPr lang="en-US" sz="1000" dirty="0">
                 <a:solidFill>
-                  <a:srgbClr val="6B6860"/>
+                  <a:srgbClr val="4A6B8A"/>
                 </a:solidFill>
                 <a:latin typeface="Calibri" pitchFamily="34" charset="0"/>
                 <a:ea typeface="Calibri" pitchFamily="34" charset="-122"/>
@@ -11512,7 +11512,7 @@
             <a:r>
               <a:rPr lang="en-US" sz="1000" u="sng" dirty="0">
                 <a:solidFill>
-                  <a:srgbClr val="6B6860"/>
+                  <a:srgbClr val="4A6B8A"/>
                 </a:solidFill>
                 <a:latin typeface="Calibri" pitchFamily="34" charset="0"/>
                 <a:ea typeface="Calibri" pitchFamily="34" charset="-122"/>
@@ -11558,7 +11558,7 @@
             <a:r>
               <a:rPr lang="en-US" sz="1000" dirty="0">
                 <a:solidFill>
-                  <a:srgbClr val="6B6860"/>
+                  <a:srgbClr val="4A6B8A"/>
                 </a:solidFill>
                 <a:latin typeface="Calibri" pitchFamily="34" charset="0"/>
                 <a:ea typeface="Calibri" pitchFamily="34" charset="-122"/>
@@ -11584,7 +11584,7 @@
     <p:bg>
       <p:bgPr>
         <a:solidFill>
-          <a:srgbClr val="F7F5F0"/>
+          <a:srgbClr val="F5F8FC"/>
         </a:solidFill>
       </p:bgPr>
     </p:bg>
@@ -11629,7 +11629,7 @@
             <a:r>
               <a:rPr lang="en-US" sz="1200" b="1" spc="150" kern="0" dirty="0">
                 <a:solidFill>
-                  <a:srgbClr val="A3690C"/>
+                  <a:srgbClr val="964F2E"/>
                 </a:solidFill>
                 <a:latin typeface="Calibri" pitchFamily="34" charset="0"/>
                 <a:ea typeface="Calibri" pitchFamily="34" charset="-122"/>
@@ -11668,7 +11668,7 @@
             <a:r>
               <a:rPr lang="en-US" sz="3000" b="1" dirty="0">
                 <a:solidFill>
-                  <a:srgbClr val="201D18"/>
+                  <a:srgbClr val="002D72"/>
                 </a:solidFill>
                 <a:latin typeface="Georgia" pitchFamily="34" charset="0"/>
                 <a:ea typeface="Georgia" pitchFamily="34" charset="-122"/>
@@ -11714,7 +11714,7 @@
             <a:r>
               <a:rPr lang="en-US" sz="1650" dirty="0">
                 <a:solidFill>
-                  <a:srgbClr val="201D18"/>
+                  <a:srgbClr val="002D72"/>
                 </a:solidFill>
                 <a:latin typeface="Calibri" pitchFamily="34" charset="0"/>
                 <a:ea typeface="Calibri" pitchFamily="34" charset="-122"/>
@@ -11738,7 +11738,7 @@
             <a:r>
               <a:rPr lang="en-US" sz="1650" dirty="0">
                 <a:solidFill>
-                  <a:srgbClr val="201D18"/>
+                  <a:srgbClr val="002D72"/>
                 </a:solidFill>
                 <a:latin typeface="Calibri" pitchFamily="34" charset="0"/>
                 <a:ea typeface="Calibri" pitchFamily="34" charset="-122"/>
@@ -11762,7 +11762,7 @@
             <a:r>
               <a:rPr lang="en-US" sz="1650" dirty="0">
                 <a:solidFill>
-                  <a:srgbClr val="201D18"/>
+                  <a:srgbClr val="002D72"/>
                 </a:solidFill>
                 <a:latin typeface="Calibri" pitchFamily="34" charset="0"/>
                 <a:ea typeface="Calibri" pitchFamily="34" charset="-122"/>
@@ -11786,7 +11786,7 @@
             <a:r>
               <a:rPr lang="en-US" sz="1650" dirty="0">
                 <a:solidFill>
-                  <a:srgbClr val="201D18"/>
+                  <a:srgbClr val="002D72"/>
                 </a:solidFill>
                 <a:latin typeface="Calibri" pitchFamily="34" charset="0"/>
                 <a:ea typeface="Calibri" pitchFamily="34" charset="-122"/>
@@ -11825,7 +11825,7 @@
             <a:r>
               <a:rPr lang="en-US" sz="1000" dirty="0">
                 <a:solidFill>
-                  <a:srgbClr val="6B6860"/>
+                  <a:srgbClr val="4A6B8A"/>
                 </a:solidFill>
                 <a:latin typeface="Calibri" pitchFamily="34" charset="0"/>
                 <a:ea typeface="Calibri" pitchFamily="34" charset="-122"/>
@@ -11839,7 +11839,7 @@
             <a:r>
               <a:rPr lang="en-US" sz="1000" u="sng" dirty="0">
                 <a:solidFill>
-                  <a:srgbClr val="6B6860"/>
+                  <a:srgbClr val="4A6B8A"/>
                 </a:solidFill>
                 <a:latin typeface="Calibri" pitchFamily="34" charset="0"/>
                 <a:ea typeface="Calibri" pitchFamily="34" charset="-122"/>
@@ -11860,7 +11860,7 @@
             <a:r>
               <a:rPr lang="en-US" sz="1000" dirty="0">
                 <a:solidFill>
-                  <a:srgbClr val="6B6860"/>
+                  <a:srgbClr val="4A6B8A"/>
                 </a:solidFill>
                 <a:latin typeface="Calibri" pitchFamily="34" charset="0"/>
                 <a:ea typeface="Calibri" pitchFamily="34" charset="-122"/>
@@ -11874,7 +11874,7 @@
             <a:r>
               <a:rPr lang="en-US" sz="1000" u="sng" dirty="0">
                 <a:solidFill>
-                  <a:srgbClr val="6B6860"/>
+                  <a:srgbClr val="4A6B8A"/>
                 </a:solidFill>
                 <a:latin typeface="Calibri" pitchFamily="34" charset="0"/>
                 <a:ea typeface="Calibri" pitchFamily="34" charset="-122"/>
@@ -11920,7 +11920,7 @@
             <a:r>
               <a:rPr lang="en-US" sz="1000" dirty="0">
                 <a:solidFill>
-                  <a:srgbClr val="6B6860"/>
+                  <a:srgbClr val="4A6B8A"/>
                 </a:solidFill>
                 <a:latin typeface="Calibri" pitchFamily="34" charset="0"/>
                 <a:ea typeface="Calibri" pitchFamily="34" charset="-122"/>
@@ -11946,7 +11946,7 @@
     <p:bg>
       <p:bgPr>
         <a:solidFill>
-          <a:srgbClr val="F7F5F0"/>
+          <a:srgbClr val="F5F8FC"/>
         </a:solidFill>
       </p:bgPr>
     </p:bg>
@@ -11991,7 +11991,7 @@
             <a:r>
               <a:rPr lang="en-US" sz="1200" b="1" spc="150" kern="0" dirty="0">
                 <a:solidFill>
-                  <a:srgbClr val="A3690C"/>
+                  <a:srgbClr val="964F2E"/>
                 </a:solidFill>
                 <a:latin typeface="Calibri" pitchFamily="34" charset="0"/>
                 <a:ea typeface="Calibri" pitchFamily="34" charset="-122"/>
@@ -12030,7 +12030,7 @@
             <a:r>
               <a:rPr lang="en-US" sz="3000" b="1" dirty="0">
                 <a:solidFill>
-                  <a:srgbClr val="201D18"/>
+                  <a:srgbClr val="002D72"/>
                 </a:solidFill>
                 <a:latin typeface="Georgia" pitchFamily="34" charset="0"/>
                 <a:ea typeface="Georgia" pitchFamily="34" charset="-122"/>
@@ -12057,11 +12057,11 @@
             <a:avLst/>
           </a:prstGeom>
           <a:solidFill>
-            <a:srgbClr val="A3690C"/>
+            <a:srgbClr val="002D72"/>
           </a:solidFill>
           <a:ln w="17780">
             <a:solidFill>
-              <a:srgbClr val="A3690C"/>
+              <a:srgbClr val="F1C400"/>
             </a:solidFill>
             <a:prstDash val="solid"/>
           </a:ln>
@@ -12133,7 +12133,7 @@
             <a:r>
               <a:rPr lang="en-US" sz="1900" dirty="0">
                 <a:solidFill>
-                  <a:srgbClr val="201D18"/>
+                  <a:srgbClr val="002D72"/>
                 </a:solidFill>
                 <a:latin typeface="Calibri" pitchFamily="34" charset="0"/>
                 <a:ea typeface="Calibri" pitchFamily="34" charset="-122"/>
@@ -12164,7 +12164,7 @@
           </a:solidFill>
           <a:ln w="17780">
             <a:solidFill>
-              <a:srgbClr val="A3690C"/>
+              <a:srgbClr val="F1C400"/>
             </a:solidFill>
             <a:prstDash val="solid"/>
           </a:ln>
@@ -12197,7 +12197,7 @@
             <a:r>
               <a:rPr lang="en-US" sz="2000" b="1" dirty="0">
                 <a:solidFill>
-                  <a:srgbClr val="A3690C"/>
+                  <a:srgbClr val="964F2E"/>
                 </a:solidFill>
                 <a:latin typeface="Georgia" pitchFamily="34" charset="0"/>
                 <a:ea typeface="Georgia" pitchFamily="34" charset="-122"/>
@@ -12236,7 +12236,7 @@
             <a:r>
               <a:rPr lang="en-US" sz="1900" dirty="0">
                 <a:solidFill>
-                  <a:srgbClr val="201D18"/>
+                  <a:srgbClr val="002D72"/>
                 </a:solidFill>
                 <a:latin typeface="Calibri" pitchFamily="34" charset="0"/>
                 <a:ea typeface="Calibri" pitchFamily="34" charset="-122"/>
@@ -12267,7 +12267,7 @@
           </a:solidFill>
           <a:ln w="17780">
             <a:solidFill>
-              <a:srgbClr val="A3690C"/>
+              <a:srgbClr val="F1C400"/>
             </a:solidFill>
             <a:prstDash val="solid"/>
           </a:ln>
@@ -12300,7 +12300,7 @@
             <a:r>
               <a:rPr lang="en-US" sz="2000" b="1" dirty="0">
                 <a:solidFill>
-                  <a:srgbClr val="A3690C"/>
+                  <a:srgbClr val="964F2E"/>
                 </a:solidFill>
                 <a:latin typeface="Georgia" pitchFamily="34" charset="0"/>
                 <a:ea typeface="Georgia" pitchFamily="34" charset="-122"/>
@@ -12339,7 +12339,7 @@
             <a:r>
               <a:rPr lang="en-US" sz="1900" dirty="0">
                 <a:solidFill>
-                  <a:srgbClr val="201D18"/>
+                  <a:srgbClr val="002D72"/>
                 </a:solidFill>
                 <a:latin typeface="Calibri" pitchFamily="34" charset="0"/>
                 <a:ea typeface="Calibri" pitchFamily="34" charset="-122"/>
@@ -12370,7 +12370,7 @@
           </a:solidFill>
           <a:ln w="17780">
             <a:solidFill>
-              <a:srgbClr val="A3690C"/>
+              <a:srgbClr val="F1C400"/>
             </a:solidFill>
             <a:prstDash val="solid"/>
           </a:ln>
@@ -12403,7 +12403,7 @@
             <a:r>
               <a:rPr lang="en-US" sz="2000" b="1" dirty="0">
                 <a:solidFill>
-                  <a:srgbClr val="A3690C"/>
+                  <a:srgbClr val="964F2E"/>
                 </a:solidFill>
                 <a:latin typeface="Georgia" pitchFamily="34" charset="0"/>
                 <a:ea typeface="Georgia" pitchFamily="34" charset="-122"/>
@@ -12442,7 +12442,7 @@
             <a:r>
               <a:rPr lang="en-US" sz="1900" dirty="0">
                 <a:solidFill>
-                  <a:srgbClr val="201D18"/>
+                  <a:srgbClr val="002D72"/>
                 </a:solidFill>
                 <a:latin typeface="Calibri" pitchFamily="34" charset="0"/>
                 <a:ea typeface="Calibri" pitchFamily="34" charset="-122"/>
@@ -12473,7 +12473,7 @@
           </a:solidFill>
           <a:ln w="17780">
             <a:solidFill>
-              <a:srgbClr val="A3690C"/>
+              <a:srgbClr val="F1C400"/>
             </a:solidFill>
             <a:prstDash val="solid"/>
           </a:ln>
@@ -12506,7 +12506,7 @@
             <a:r>
               <a:rPr lang="en-US" sz="2000" b="1" dirty="0">
                 <a:solidFill>
-                  <a:srgbClr val="A3690C"/>
+                  <a:srgbClr val="964F2E"/>
                 </a:solidFill>
                 <a:latin typeface="Georgia" pitchFamily="34" charset="0"/>
                 <a:ea typeface="Georgia" pitchFamily="34" charset="-122"/>
@@ -12545,7 +12545,7 @@
             <a:r>
               <a:rPr lang="en-US" sz="1900" dirty="0">
                 <a:solidFill>
-                  <a:srgbClr val="201D18"/>
+                  <a:srgbClr val="002D72"/>
                 </a:solidFill>
                 <a:latin typeface="Calibri" pitchFamily="34" charset="0"/>
                 <a:ea typeface="Calibri" pitchFamily="34" charset="-122"/>
@@ -12584,7 +12584,7 @@
             <a:r>
               <a:rPr lang="en-US" sz="1300" i="1" dirty="0">
                 <a:solidFill>
-                  <a:srgbClr val="6B6860"/>
+                  <a:srgbClr val="4A6B8A"/>
                 </a:solidFill>
                 <a:latin typeface="Calibri" pitchFamily="34" charset="0"/>
                 <a:ea typeface="Calibri" pitchFamily="34" charset="-122"/>
@@ -12623,7 +12623,7 @@
             <a:r>
               <a:rPr lang="en-US" sz="1000" dirty="0">
                 <a:solidFill>
-                  <a:srgbClr val="6B6860"/>
+                  <a:srgbClr val="4A6B8A"/>
                 </a:solidFill>
                 <a:latin typeface="Calibri" pitchFamily="34" charset="0"/>
                 <a:ea typeface="Calibri" pitchFamily="34" charset="-122"/>
@@ -12649,7 +12649,7 @@
     <p:bg>
       <p:bgPr>
         <a:solidFill>
-          <a:srgbClr val="0F6E67"/>
+          <a:srgbClr val="002D72"/>
         </a:solidFill>
       </p:bgPr>
     </p:bg>
@@ -12694,7 +12694,7 @@
             <a:r>
               <a:rPr lang="en-US" sz="1300" b="1" spc="200" kern="0" dirty="0">
                 <a:solidFill>
-                  <a:srgbClr val="DDEFEC"/>
+                  <a:srgbClr val="DCEBFA"/>
                 </a:solidFill>
                 <a:latin typeface="Calibri" pitchFamily="34" charset="0"/>
                 <a:ea typeface="Calibri" pitchFamily="34" charset="-122"/>
@@ -12778,7 +12778,7 @@
             <a:r>
               <a:rPr lang="en-US" sz="1400" dirty="0">
                 <a:solidFill>
-                  <a:srgbClr val="D7ECE9"/>
+                  <a:srgbClr val="DCEBFA"/>
                 </a:solidFill>
                 <a:latin typeface="Calibri" pitchFamily="34" charset="0"/>
                 <a:ea typeface="Calibri" pitchFamily="34" charset="-122"/>
@@ -12804,7 +12804,7 @@
     <p:bg>
       <p:bgPr>
         <a:solidFill>
-          <a:srgbClr val="F7F5F0"/>
+          <a:srgbClr val="F5F8FC"/>
         </a:solidFill>
       </p:bgPr>
     </p:bg>
@@ -12849,7 +12849,7 @@
             <a:r>
               <a:rPr lang="en-US" sz="1200" b="1" spc="150" kern="0" dirty="0">
                 <a:solidFill>
-                  <a:srgbClr val="A3690C"/>
+                  <a:srgbClr val="964F2E"/>
                 </a:solidFill>
                 <a:latin typeface="Calibri" pitchFamily="34" charset="0"/>
                 <a:ea typeface="Calibri" pitchFamily="34" charset="-122"/>
@@ -12888,7 +12888,7 @@
             <a:r>
               <a:rPr lang="en-US" sz="3000" b="1" dirty="0">
                 <a:solidFill>
-                  <a:srgbClr val="201D18"/>
+                  <a:srgbClr val="002D72"/>
                 </a:solidFill>
                 <a:latin typeface="Georgia" pitchFamily="34" charset="0"/>
                 <a:ea typeface="Georgia" pitchFamily="34" charset="-122"/>
@@ -12930,7 +12930,7 @@
             <a:r>
               <a:rPr lang="en-US" sz="1600" i="1" dirty="0">
                 <a:solidFill>
-                  <a:srgbClr val="201D18"/>
+                  <a:srgbClr val="002D72"/>
                 </a:solidFill>
                 <a:latin typeface="Calibri" pitchFamily="34" charset="0"/>
                 <a:ea typeface="Calibri" pitchFamily="34" charset="-122"/>
@@ -12957,11 +12957,11 @@
             <a:avLst/>
           </a:prstGeom>
           <a:solidFill>
-            <a:srgbClr val="ECDCBD"/>
+            <a:srgbClr val="F6E7C9"/>
           </a:solidFill>
           <a:ln w="12700">
             <a:solidFill>
-              <a:srgbClr val="A3690C"/>
+              <a:srgbClr val="F1C400"/>
             </a:solidFill>
             <a:prstDash val="solid"/>
           </a:ln>
@@ -12994,7 +12994,7 @@
             <a:r>
               <a:rPr lang="en-US" sz="1300" b="1" dirty="0">
                 <a:solidFill>
-                  <a:srgbClr val="A3690C"/>
+                  <a:srgbClr val="964F2E"/>
                 </a:solidFill>
                 <a:latin typeface="Calibri" pitchFamily="34" charset="0"/>
                 <a:ea typeface="Calibri" pitchFamily="34" charset="-122"/>
@@ -13033,7 +13033,7 @@
             <a:r>
               <a:rPr lang="en-US" sz="1450" dirty="0">
                 <a:solidFill>
-                  <a:srgbClr val="201D18"/>
+                  <a:srgbClr val="002D72"/>
                 </a:solidFill>
                 <a:latin typeface="Calibri" pitchFamily="34" charset="0"/>
                 <a:ea typeface="Calibri" pitchFamily="34" charset="-122"/>
@@ -13060,11 +13060,11 @@
             <a:avLst/>
           </a:prstGeom>
           <a:solidFill>
-            <a:srgbClr val="ECDCBD"/>
+            <a:srgbClr val="F6E7C9"/>
           </a:solidFill>
           <a:ln w="12700">
             <a:solidFill>
-              <a:srgbClr val="A3690C"/>
+              <a:srgbClr val="F1C400"/>
             </a:solidFill>
             <a:prstDash val="solid"/>
           </a:ln>
@@ -13097,7 +13097,7 @@
             <a:r>
               <a:rPr lang="en-US" sz="1300" b="1" dirty="0">
                 <a:solidFill>
-                  <a:srgbClr val="A3690C"/>
+                  <a:srgbClr val="964F2E"/>
                 </a:solidFill>
                 <a:latin typeface="Calibri" pitchFamily="34" charset="0"/>
                 <a:ea typeface="Calibri" pitchFamily="34" charset="-122"/>
@@ -13136,7 +13136,7 @@
             <a:r>
               <a:rPr lang="en-US" sz="1450" dirty="0">
                 <a:solidFill>
-                  <a:srgbClr val="201D18"/>
+                  <a:srgbClr val="002D72"/>
                 </a:solidFill>
                 <a:latin typeface="Calibri" pitchFamily="34" charset="0"/>
                 <a:ea typeface="Calibri" pitchFamily="34" charset="-122"/>
@@ -13163,11 +13163,11 @@
             <a:avLst/>
           </a:prstGeom>
           <a:solidFill>
-            <a:srgbClr val="ECDCBD"/>
+            <a:srgbClr val="F6E7C9"/>
           </a:solidFill>
           <a:ln w="12700">
             <a:solidFill>
-              <a:srgbClr val="A3690C"/>
+              <a:srgbClr val="F1C400"/>
             </a:solidFill>
             <a:prstDash val="solid"/>
           </a:ln>
@@ -13200,7 +13200,7 @@
             <a:r>
               <a:rPr lang="en-US" sz="1300" b="1" dirty="0">
                 <a:solidFill>
-                  <a:srgbClr val="A3690C"/>
+                  <a:srgbClr val="964F2E"/>
                 </a:solidFill>
                 <a:latin typeface="Calibri" pitchFamily="34" charset="0"/>
                 <a:ea typeface="Calibri" pitchFamily="34" charset="-122"/>
@@ -13239,7 +13239,7 @@
             <a:r>
               <a:rPr lang="en-US" sz="1450" dirty="0">
                 <a:solidFill>
-                  <a:srgbClr val="201D18"/>
+                  <a:srgbClr val="002D72"/>
                 </a:solidFill>
                 <a:latin typeface="Calibri" pitchFamily="34" charset="0"/>
                 <a:ea typeface="Calibri" pitchFamily="34" charset="-122"/>
@@ -13266,11 +13266,11 @@
             <a:avLst/>
           </a:prstGeom>
           <a:solidFill>
-            <a:srgbClr val="ECDCBD"/>
+            <a:srgbClr val="F6E7C9"/>
           </a:solidFill>
           <a:ln w="12700">
             <a:solidFill>
-              <a:srgbClr val="A3690C"/>
+              <a:srgbClr val="F1C400"/>
             </a:solidFill>
             <a:prstDash val="solid"/>
           </a:ln>
@@ -13303,7 +13303,7 @@
             <a:r>
               <a:rPr lang="en-US" sz="1300" b="1" dirty="0">
                 <a:solidFill>
-                  <a:srgbClr val="A3690C"/>
+                  <a:srgbClr val="964F2E"/>
                 </a:solidFill>
                 <a:latin typeface="Calibri" pitchFamily="34" charset="0"/>
                 <a:ea typeface="Calibri" pitchFamily="34" charset="-122"/>
@@ -13342,7 +13342,7 @@
             <a:r>
               <a:rPr lang="en-US" sz="1450" dirty="0">
                 <a:solidFill>
-                  <a:srgbClr val="201D18"/>
+                  <a:srgbClr val="002D72"/>
                 </a:solidFill>
                 <a:latin typeface="Calibri" pitchFamily="34" charset="0"/>
                 <a:ea typeface="Calibri" pitchFamily="34" charset="-122"/>
@@ -13369,11 +13369,11 @@
             <a:avLst/>
           </a:prstGeom>
           <a:solidFill>
-            <a:srgbClr val="ECDCBD"/>
+            <a:srgbClr val="F6E7C9"/>
           </a:solidFill>
           <a:ln w="12700">
             <a:solidFill>
-              <a:srgbClr val="A3690C"/>
+              <a:srgbClr val="F1C400"/>
             </a:solidFill>
             <a:prstDash val="solid"/>
           </a:ln>
@@ -13406,7 +13406,7 @@
             <a:r>
               <a:rPr lang="en-US" sz="1300" b="1" dirty="0">
                 <a:solidFill>
-                  <a:srgbClr val="A3690C"/>
+                  <a:srgbClr val="964F2E"/>
                 </a:solidFill>
                 <a:latin typeface="Calibri" pitchFamily="34" charset="0"/>
                 <a:ea typeface="Calibri" pitchFamily="34" charset="-122"/>
@@ -13445,7 +13445,7 @@
             <a:r>
               <a:rPr lang="en-US" sz="1450" dirty="0">
                 <a:solidFill>
-                  <a:srgbClr val="201D18"/>
+                  <a:srgbClr val="002D72"/>
                 </a:solidFill>
                 <a:latin typeface="Calibri" pitchFamily="34" charset="0"/>
                 <a:ea typeface="Calibri" pitchFamily="34" charset="-122"/>
@@ -13484,7 +13484,7 @@
             <a:r>
               <a:rPr lang="en-US" sz="1000" dirty="0">
                 <a:solidFill>
-                  <a:srgbClr val="6B6860"/>
+                  <a:srgbClr val="4A6B8A"/>
                 </a:solidFill>
                 <a:latin typeface="Calibri" pitchFamily="34" charset="0"/>
                 <a:ea typeface="Calibri" pitchFamily="34" charset="-122"/>
@@ -13510,7 +13510,7 @@
     <p:bg>
       <p:bgPr>
         <a:solidFill>
-          <a:srgbClr val="F7F5F0"/>
+          <a:srgbClr val="F5F8FC"/>
         </a:solidFill>
       </p:bgPr>
     </p:bg>
@@ -13555,7 +13555,7 @@
             <a:r>
               <a:rPr lang="en-US" sz="1200" b="1" spc="150" kern="0" dirty="0">
                 <a:solidFill>
-                  <a:srgbClr val="A3690C"/>
+                  <a:srgbClr val="964F2E"/>
                 </a:solidFill>
                 <a:latin typeface="Calibri" pitchFamily="34" charset="0"/>
                 <a:ea typeface="Calibri" pitchFamily="34" charset="-122"/>
@@ -13594,7 +13594,7 @@
             <a:r>
               <a:rPr lang="en-US" sz="3000" b="1" dirty="0">
                 <a:solidFill>
-                  <a:srgbClr val="201D18"/>
+                  <a:srgbClr val="002D72"/>
                 </a:solidFill>
                 <a:latin typeface="Georgia" pitchFamily="34" charset="0"/>
                 <a:ea typeface="Georgia" pitchFamily="34" charset="-122"/>
@@ -13625,7 +13625,7 @@
           </a:solidFill>
           <a:ln w="12700">
             <a:solidFill>
-              <a:srgbClr val="E2DDD2"/>
+              <a:srgbClr val="D6E4F2"/>
             </a:solidFill>
             <a:prstDash val="solid"/>
           </a:ln>
@@ -13661,7 +13661,7 @@
             <a:r>
               <a:rPr lang="en-US" sz="1500" b="1" dirty="0">
                 <a:solidFill>
-                  <a:srgbClr val="0F6E67"/>
+                  <a:srgbClr val="002D72"/>
                 </a:solidFill>
                 <a:latin typeface="Calibri" pitchFamily="34" charset="0"/>
                 <a:ea typeface="Calibri" pitchFamily="34" charset="-122"/>
@@ -13703,7 +13703,7 @@
             <a:r>
               <a:rPr lang="en-US" sz="1250" dirty="0">
                 <a:solidFill>
-                  <a:srgbClr val="201D18"/>
+                  <a:srgbClr val="002D72"/>
                 </a:solidFill>
                 <a:latin typeface="Calibri" pitchFamily="34" charset="0"/>
                 <a:ea typeface="Calibri" pitchFamily="34" charset="-122"/>
@@ -13730,11 +13730,11 @@
             <a:avLst/>
           </a:prstGeom>
           <a:solidFill>
-            <a:srgbClr val="F7F5F0"/>
+            <a:srgbClr val="F5F8FC"/>
           </a:solidFill>
           <a:ln w="12700">
             <a:solidFill>
-              <a:srgbClr val="E2DDD2"/>
+              <a:srgbClr val="D6E4F2"/>
             </a:solidFill>
             <a:prstDash val="solid"/>
           </a:ln>
@@ -13770,7 +13770,7 @@
             <a:r>
               <a:rPr lang="en-US" sz="1500" b="1" dirty="0">
                 <a:solidFill>
-                  <a:srgbClr val="0F6E67"/>
+                  <a:srgbClr val="002D72"/>
                 </a:solidFill>
                 <a:latin typeface="Calibri" pitchFamily="34" charset="0"/>
                 <a:ea typeface="Calibri" pitchFamily="34" charset="-122"/>
@@ -13812,7 +13812,7 @@
             <a:r>
               <a:rPr lang="en-US" sz="1250" dirty="0">
                 <a:solidFill>
-                  <a:srgbClr val="201D18"/>
+                  <a:srgbClr val="002D72"/>
                 </a:solidFill>
                 <a:latin typeface="Calibri" pitchFamily="34" charset="0"/>
                 <a:ea typeface="Calibri" pitchFamily="34" charset="-122"/>
@@ -13843,7 +13843,7 @@
           </a:solidFill>
           <a:ln w="12700">
             <a:solidFill>
-              <a:srgbClr val="E2DDD2"/>
+              <a:srgbClr val="D6E4F2"/>
             </a:solidFill>
             <a:prstDash val="solid"/>
           </a:ln>
@@ -13879,7 +13879,7 @@
             <a:r>
               <a:rPr lang="en-US" sz="1500" b="1" dirty="0">
                 <a:solidFill>
-                  <a:srgbClr val="0F6E67"/>
+                  <a:srgbClr val="002D72"/>
                 </a:solidFill>
                 <a:latin typeface="Calibri" pitchFamily="34" charset="0"/>
                 <a:ea typeface="Calibri" pitchFamily="34" charset="-122"/>
@@ -13921,7 +13921,7 @@
             <a:r>
               <a:rPr lang="en-US" sz="1250" dirty="0">
                 <a:solidFill>
-                  <a:srgbClr val="201D18"/>
+                  <a:srgbClr val="002D72"/>
                 </a:solidFill>
                 <a:latin typeface="Calibri" pitchFamily="34" charset="0"/>
                 <a:ea typeface="Calibri" pitchFamily="34" charset="-122"/>
@@ -13948,11 +13948,11 @@
             <a:avLst/>
           </a:prstGeom>
           <a:solidFill>
-            <a:srgbClr val="F7F5F0"/>
+            <a:srgbClr val="F5F8FC"/>
           </a:solidFill>
           <a:ln w="12700">
             <a:solidFill>
-              <a:srgbClr val="E2DDD2"/>
+              <a:srgbClr val="D6E4F2"/>
             </a:solidFill>
             <a:prstDash val="solid"/>
           </a:ln>
@@ -13988,7 +13988,7 @@
             <a:r>
               <a:rPr lang="en-US" sz="1500" b="1" dirty="0">
                 <a:solidFill>
-                  <a:srgbClr val="0F6E67"/>
+                  <a:srgbClr val="002D72"/>
                 </a:solidFill>
                 <a:latin typeface="Calibri" pitchFamily="34" charset="0"/>
                 <a:ea typeface="Calibri" pitchFamily="34" charset="-122"/>
@@ -14030,7 +14030,7 @@
             <a:r>
               <a:rPr lang="en-US" sz="1250" dirty="0">
                 <a:solidFill>
-                  <a:srgbClr val="201D18"/>
+                  <a:srgbClr val="002D72"/>
                 </a:solidFill>
                 <a:latin typeface="Calibri" pitchFamily="34" charset="0"/>
                 <a:ea typeface="Calibri" pitchFamily="34" charset="-122"/>
@@ -14069,7 +14069,7 @@
             <a:r>
               <a:rPr lang="en-US" sz="1000" dirty="0">
                 <a:solidFill>
-                  <a:srgbClr val="6B6860"/>
+                  <a:srgbClr val="4A6B8A"/>
                 </a:solidFill>
                 <a:latin typeface="Calibri" pitchFamily="34" charset="0"/>
                 <a:ea typeface="Calibri" pitchFamily="34" charset="-122"/>
@@ -14095,7 +14095,7 @@
     <p:bg>
       <p:bgPr>
         <a:solidFill>
-          <a:srgbClr val="12161A"/>
+          <a:srgbClr val="68ACE5"/>
         </a:solidFill>
       </p:bgPr>
     </p:bg>
@@ -14143,7 +14143,7 @@
             <a:r>
               <a:rPr lang="en-US" sz="2400" i="1" dirty="0">
                 <a:solidFill>
-                  <a:srgbClr val="E8E4DB"/>
+                  <a:srgbClr val="002D72"/>
                 </a:solidFill>
                 <a:latin typeface="Georgia" pitchFamily="34" charset="0"/>
                 <a:ea typeface="Georgia" pitchFamily="34" charset="-122"/>
@@ -14185,7 +14185,7 @@
             <a:r>
               <a:rPr lang="en-US" sz="2400" b="1" i="1" dirty="0">
                 <a:solidFill>
-                  <a:srgbClr val="A3690C"/>
+                  <a:srgbClr val="002D72"/>
                 </a:solidFill>
                 <a:latin typeface="Georgia" pitchFamily="34" charset="0"/>
                 <a:ea typeface="Georgia" pitchFamily="34" charset="-122"/>
@@ -14227,7 +14227,7 @@
             <a:r>
               <a:rPr lang="en-US" sz="1600" dirty="0">
                 <a:solidFill>
-                  <a:srgbClr val="9B968C"/>
+                  <a:srgbClr val="002D72"/>
                 </a:solidFill>
                 <a:latin typeface="Calibri" pitchFamily="34" charset="0"/>
                 <a:ea typeface="Calibri" pitchFamily="34" charset="-122"/>
@@ -14266,7 +14266,7 @@
             <a:r>
               <a:rPr lang="en-US" sz="1000" dirty="0">
                 <a:solidFill>
-                  <a:srgbClr val="6B6860"/>
+                  <a:srgbClr val="002D72"/>
                 </a:solidFill>
                 <a:latin typeface="Calibri" pitchFamily="34" charset="0"/>
                 <a:ea typeface="Calibri" pitchFamily="34" charset="-122"/>
@@ -14292,7 +14292,7 @@
     <p:bg>
       <p:bgPr>
         <a:solidFill>
-          <a:srgbClr val="12161A"/>
+          <a:srgbClr val="68ACE5"/>
         </a:solidFill>
       </p:bgPr>
     </p:bg>
@@ -14337,7 +14337,7 @@
             <a:r>
               <a:rPr lang="en-US" sz="4400" b="1" dirty="0">
                 <a:solidFill>
-                  <a:srgbClr val="E8E4DB"/>
+                  <a:srgbClr val="002D72"/>
                 </a:solidFill>
                 <a:latin typeface="Georgia" pitchFamily="34" charset="0"/>
                 <a:ea typeface="Georgia" pitchFamily="34" charset="-122"/>
@@ -14376,7 +14376,7 @@
             <a:r>
               <a:rPr lang="en-US" sz="1600" i="1" dirty="0">
                 <a:solidFill>
-                  <a:srgbClr val="A3690C"/>
+                  <a:srgbClr val="002D72"/>
                 </a:solidFill>
                 <a:latin typeface="Calibri" pitchFamily="34" charset="0"/>
                 <a:ea typeface="Calibri" pitchFamily="34" charset="-122"/>
@@ -14415,7 +14415,7 @@
             <a:r>
               <a:rPr lang="en-US" sz="1500" b="1" dirty="0">
                 <a:solidFill>
-                  <a:srgbClr val="FFFFFF"/>
+                  <a:srgbClr val="002D72"/>
                 </a:solidFill>
                 <a:latin typeface="Calibri" pitchFamily="34" charset="0"/>
                 <a:ea typeface="Calibri" pitchFamily="34" charset="-122"/>
@@ -14454,7 +14454,7 @@
             <a:r>
               <a:rPr lang="en-US" sz="1250" dirty="0">
                 <a:solidFill>
-                  <a:srgbClr val="9B968C"/>
+                  <a:srgbClr val="002D72"/>
                 </a:solidFill>
                 <a:latin typeface="Calibri" pitchFamily="34" charset="0"/>
                 <a:ea typeface="Calibri" pitchFamily="34" charset="-122"/>
@@ -14493,7 +14493,7 @@
             <a:r>
               <a:rPr lang="en-US" sz="1500" b="1" dirty="0">
                 <a:solidFill>
-                  <a:srgbClr val="FFFFFF"/>
+                  <a:srgbClr val="002D72"/>
                 </a:solidFill>
                 <a:latin typeface="Calibri" pitchFamily="34" charset="0"/>
                 <a:ea typeface="Calibri" pitchFamily="34" charset="-122"/>
@@ -14532,7 +14532,7 @@
             <a:r>
               <a:rPr lang="en-US" sz="1250" dirty="0">
                 <a:solidFill>
-                  <a:srgbClr val="9B968C"/>
+                  <a:srgbClr val="002D72"/>
                 </a:solidFill>
                 <a:latin typeface="Calibri" pitchFamily="34" charset="0"/>
                 <a:ea typeface="Calibri" pitchFamily="34" charset="-122"/>
@@ -14571,7 +14571,7 @@
             <a:r>
               <a:rPr lang="en-US" sz="1500" b="1" dirty="0">
                 <a:solidFill>
-                  <a:srgbClr val="FFFFFF"/>
+                  <a:srgbClr val="002D72"/>
                 </a:solidFill>
                 <a:latin typeface="Calibri" pitchFamily="34" charset="0"/>
                 <a:ea typeface="Calibri" pitchFamily="34" charset="-122"/>
@@ -14610,7 +14610,7 @@
             <a:r>
               <a:rPr lang="en-US" sz="1250" dirty="0">
                 <a:solidFill>
-                  <a:srgbClr val="9B968C"/>
+                  <a:srgbClr val="002D72"/>
                 </a:solidFill>
                 <a:latin typeface="Calibri" pitchFamily="34" charset="0"/>
                 <a:ea typeface="Calibri" pitchFamily="34" charset="-122"/>
@@ -14639,7 +14639,7 @@
           <a:noFill/>
           <a:ln w="25400">
             <a:solidFill>
-              <a:srgbClr val="A3690C"/>
+              <a:srgbClr val="F1C400"/>
             </a:solidFill>
             <a:prstDash val="solid"/>
           </a:ln>
@@ -14672,7 +14672,7 @@
             <a:r>
               <a:rPr lang="en-US" sz="1200" dirty="0">
                 <a:solidFill>
-                  <a:srgbClr val="9B968C"/>
+                  <a:srgbClr val="002D72"/>
                 </a:solidFill>
                 <a:latin typeface="Calibri" pitchFamily="34" charset="0"/>
                 <a:ea typeface="Calibri" pitchFamily="34" charset="-122"/>
@@ -14711,7 +14711,7 @@
             <a:r>
               <a:rPr lang="en-US" sz="1000" dirty="0">
                 <a:solidFill>
-                  <a:srgbClr val="6B6860"/>
+                  <a:srgbClr val="002D72"/>
                 </a:solidFill>
                 <a:latin typeface="Calibri" pitchFamily="34" charset="0"/>
                 <a:ea typeface="Calibri" pitchFamily="34" charset="-122"/>
@@ -14737,7 +14737,7 @@
     <p:bg>
       <p:bgPr>
         <a:solidFill>
-          <a:srgbClr val="F7F5F0"/>
+          <a:srgbClr val="F5F8FC"/>
         </a:solidFill>
       </p:bgPr>
     </p:bg>
@@ -14782,7 +14782,7 @@
             <a:r>
               <a:rPr lang="en-US" sz="1200" b="1" spc="150" kern="0" dirty="0">
                 <a:solidFill>
-                  <a:srgbClr val="A3690C"/>
+                  <a:srgbClr val="964F2E"/>
                 </a:solidFill>
                 <a:latin typeface="Calibri" pitchFamily="34" charset="0"/>
                 <a:ea typeface="Calibri" pitchFamily="34" charset="-122"/>
@@ -14821,7 +14821,7 @@
             <a:r>
               <a:rPr lang="en-US" sz="3000" b="1" dirty="0">
                 <a:solidFill>
-                  <a:srgbClr val="201D18"/>
+                  <a:srgbClr val="002D72"/>
                 </a:solidFill>
                 <a:latin typeface="Georgia" pitchFamily="34" charset="0"/>
                 <a:ea typeface="Georgia" pitchFamily="34" charset="-122"/>
@@ -14848,7 +14848,7 @@
             <a:avLst/>
           </a:prstGeom>
           <a:solidFill>
-            <a:srgbClr val="0F6E67"/>
+            <a:srgbClr val="002D72"/>
           </a:solidFill>
           <a:ln/>
         </p:spPr>
@@ -14880,7 +14880,7 @@
             <a:r>
               <a:rPr lang="en-US" sz="1500" b="1" dirty="0">
                 <a:solidFill>
-                  <a:srgbClr val="201D18"/>
+                  <a:srgbClr val="002D72"/>
                 </a:solidFill>
                 <a:latin typeface="Calibri" pitchFamily="34" charset="0"/>
                 <a:ea typeface="Calibri" pitchFamily="34" charset="-122"/>
@@ -14919,7 +14919,7 @@
             <a:r>
               <a:rPr lang="en-US" sz="1200" dirty="0">
                 <a:solidFill>
-                  <a:srgbClr val="6B6860"/>
+                  <a:srgbClr val="4A6B8A"/>
                 </a:solidFill>
                 <a:latin typeface="Calibri" pitchFamily="34" charset="0"/>
                 <a:ea typeface="Calibri" pitchFamily="34" charset="-122"/>
@@ -14946,7 +14946,7 @@
             <a:avLst/>
           </a:prstGeom>
           <a:solidFill>
-            <a:srgbClr val="0F6E67"/>
+            <a:srgbClr val="002D72"/>
           </a:solidFill>
           <a:ln/>
         </p:spPr>
@@ -14978,7 +14978,7 @@
             <a:r>
               <a:rPr lang="en-US" sz="1500" b="1" dirty="0">
                 <a:solidFill>
-                  <a:srgbClr val="201D18"/>
+                  <a:srgbClr val="002D72"/>
                 </a:solidFill>
                 <a:latin typeface="Calibri" pitchFamily="34" charset="0"/>
                 <a:ea typeface="Calibri" pitchFamily="34" charset="-122"/>
@@ -15017,7 +15017,7 @@
             <a:r>
               <a:rPr lang="en-US" sz="1200" dirty="0">
                 <a:solidFill>
-                  <a:srgbClr val="6B6860"/>
+                  <a:srgbClr val="4A6B8A"/>
                 </a:solidFill>
                 <a:latin typeface="Calibri" pitchFamily="34" charset="0"/>
                 <a:ea typeface="Calibri" pitchFamily="34" charset="-122"/>
@@ -15044,7 +15044,7 @@
             <a:avLst/>
           </a:prstGeom>
           <a:solidFill>
-            <a:srgbClr val="0F6E67"/>
+            <a:srgbClr val="002D72"/>
           </a:solidFill>
           <a:ln/>
         </p:spPr>
@@ -15076,7 +15076,7 @@
             <a:r>
               <a:rPr lang="en-US" sz="1500" b="1" dirty="0">
                 <a:solidFill>
-                  <a:srgbClr val="201D18"/>
+                  <a:srgbClr val="002D72"/>
                 </a:solidFill>
                 <a:latin typeface="Calibri" pitchFamily="34" charset="0"/>
                 <a:ea typeface="Calibri" pitchFamily="34" charset="-122"/>
@@ -15115,7 +15115,7 @@
             <a:r>
               <a:rPr lang="en-US" sz="1200" dirty="0">
                 <a:solidFill>
-                  <a:srgbClr val="6B6860"/>
+                  <a:srgbClr val="4A6B8A"/>
                 </a:solidFill>
                 <a:latin typeface="Calibri" pitchFamily="34" charset="0"/>
                 <a:ea typeface="Calibri" pitchFamily="34" charset="-122"/>
@@ -15142,7 +15142,7 @@
             <a:avLst/>
           </a:prstGeom>
           <a:solidFill>
-            <a:srgbClr val="0F6E67"/>
+            <a:srgbClr val="002D72"/>
           </a:solidFill>
           <a:ln/>
         </p:spPr>
@@ -15174,7 +15174,7 @@
             <a:r>
               <a:rPr lang="en-US" sz="1500" b="1" dirty="0">
                 <a:solidFill>
-                  <a:srgbClr val="201D18"/>
+                  <a:srgbClr val="002D72"/>
                 </a:solidFill>
                 <a:latin typeface="Calibri" pitchFamily="34" charset="0"/>
                 <a:ea typeface="Calibri" pitchFamily="34" charset="-122"/>
@@ -15213,7 +15213,7 @@
             <a:r>
               <a:rPr lang="en-US" sz="1200" dirty="0">
                 <a:solidFill>
-                  <a:srgbClr val="6B6860"/>
+                  <a:srgbClr val="4A6B8A"/>
                 </a:solidFill>
                 <a:latin typeface="Calibri" pitchFamily="34" charset="0"/>
                 <a:ea typeface="Calibri" pitchFamily="34" charset="-122"/>
@@ -15244,7 +15244,7 @@
           </a:solidFill>
           <a:ln w="12700">
             <a:solidFill>
-              <a:srgbClr val="E2DDD2"/>
+              <a:srgbClr val="D6E4F2"/>
             </a:solidFill>
             <a:prstDash val="solid"/>
           </a:ln>
@@ -15277,7 +15277,7 @@
             <a:r>
               <a:rPr lang="en-US" sz="2200" b="1" dirty="0">
                 <a:solidFill>
-                  <a:srgbClr val="A3690C"/>
+                  <a:srgbClr val="964F2E"/>
                 </a:solidFill>
                 <a:latin typeface="Georgia" pitchFamily="34" charset="0"/>
                 <a:ea typeface="Georgia" pitchFamily="34" charset="-122"/>
@@ -15319,7 +15319,7 @@
             <a:r>
               <a:rPr lang="en-US" sz="1150" dirty="0">
                 <a:solidFill>
-                  <a:srgbClr val="201D18"/>
+                  <a:srgbClr val="002D72"/>
                 </a:solidFill>
                 <a:latin typeface="Calibri" pitchFamily="34" charset="0"/>
                 <a:ea typeface="Calibri" pitchFamily="34" charset="-122"/>
@@ -15350,7 +15350,7 @@
           </a:solidFill>
           <a:ln w="12700">
             <a:solidFill>
-              <a:srgbClr val="E2DDD2"/>
+              <a:srgbClr val="D6E4F2"/>
             </a:solidFill>
             <a:prstDash val="solid"/>
           </a:ln>
@@ -15383,7 +15383,7 @@
             <a:r>
               <a:rPr lang="en-US" sz="2200" b="1" dirty="0">
                 <a:solidFill>
-                  <a:srgbClr val="A3690C"/>
+                  <a:srgbClr val="964F2E"/>
                 </a:solidFill>
                 <a:latin typeface="Georgia" pitchFamily="34" charset="0"/>
                 <a:ea typeface="Georgia" pitchFamily="34" charset="-122"/>
@@ -15425,7 +15425,7 @@
             <a:r>
               <a:rPr lang="en-US" sz="1150" dirty="0">
                 <a:solidFill>
-                  <a:srgbClr val="201D18"/>
+                  <a:srgbClr val="002D72"/>
                 </a:solidFill>
                 <a:latin typeface="Calibri" pitchFamily="34" charset="0"/>
                 <a:ea typeface="Calibri" pitchFamily="34" charset="-122"/>
@@ -15456,7 +15456,7 @@
           </a:solidFill>
           <a:ln w="12700">
             <a:solidFill>
-              <a:srgbClr val="E2DDD2"/>
+              <a:srgbClr val="D6E4F2"/>
             </a:solidFill>
             <a:prstDash val="solid"/>
           </a:ln>
@@ -15489,7 +15489,7 @@
             <a:r>
               <a:rPr lang="en-US" sz="2200" b="1" dirty="0">
                 <a:solidFill>
-                  <a:srgbClr val="A3690C"/>
+                  <a:srgbClr val="964F2E"/>
                 </a:solidFill>
                 <a:latin typeface="Georgia" pitchFamily="34" charset="0"/>
                 <a:ea typeface="Georgia" pitchFamily="34" charset="-122"/>
@@ -15531,7 +15531,7 @@
             <a:r>
               <a:rPr lang="en-US" sz="1150" dirty="0">
                 <a:solidFill>
-                  <a:srgbClr val="201D18"/>
+                  <a:srgbClr val="002D72"/>
                 </a:solidFill>
                 <a:latin typeface="Calibri" pitchFamily="34" charset="0"/>
                 <a:ea typeface="Calibri" pitchFamily="34" charset="-122"/>
@@ -15562,7 +15562,7 @@
           </a:solidFill>
           <a:ln w="12700">
             <a:solidFill>
-              <a:srgbClr val="E2DDD2"/>
+              <a:srgbClr val="D6E4F2"/>
             </a:solidFill>
             <a:prstDash val="solid"/>
           </a:ln>
@@ -15595,7 +15595,7 @@
             <a:r>
               <a:rPr lang="en-US" sz="2200" b="1" dirty="0">
                 <a:solidFill>
-                  <a:srgbClr val="A3690C"/>
+                  <a:srgbClr val="964F2E"/>
                 </a:solidFill>
                 <a:latin typeface="Georgia" pitchFamily="34" charset="0"/>
                 <a:ea typeface="Georgia" pitchFamily="34" charset="-122"/>
@@ -15637,7 +15637,7 @@
             <a:r>
               <a:rPr lang="en-US" sz="1150" dirty="0">
                 <a:solidFill>
-                  <a:srgbClr val="201D18"/>
+                  <a:srgbClr val="002D72"/>
                 </a:solidFill>
                 <a:latin typeface="Calibri" pitchFamily="34" charset="0"/>
                 <a:ea typeface="Calibri" pitchFamily="34" charset="-122"/>
@@ -15676,7 +15676,7 @@
             <a:r>
               <a:rPr lang="en-US" sz="1000" dirty="0">
                 <a:solidFill>
-                  <a:srgbClr val="6B6860"/>
+                  <a:srgbClr val="4A6B8A"/>
                 </a:solidFill>
                 <a:latin typeface="Calibri" pitchFamily="34" charset="0"/>
                 <a:ea typeface="Calibri" pitchFamily="34" charset="-122"/>
@@ -15690,7 +15690,7 @@
             <a:r>
               <a:rPr lang="en-US" sz="1000" u="sng" dirty="0">
                 <a:solidFill>
-                  <a:srgbClr val="6B6860"/>
+                  <a:srgbClr val="4A6B8A"/>
                 </a:solidFill>
                 <a:latin typeface="Calibri" pitchFamily="34" charset="0"/>
                 <a:ea typeface="Calibri" pitchFamily="34" charset="-122"/>
@@ -15711,7 +15711,7 @@
             <a:r>
               <a:rPr lang="en-US" sz="1000" dirty="0">
                 <a:solidFill>
-                  <a:srgbClr val="6B6860"/>
+                  <a:srgbClr val="4A6B8A"/>
                 </a:solidFill>
                 <a:latin typeface="Calibri" pitchFamily="34" charset="0"/>
                 <a:ea typeface="Calibri" pitchFamily="34" charset="-122"/>
@@ -15725,7 +15725,7 @@
             <a:r>
               <a:rPr lang="en-US" sz="1000" u="sng" dirty="0">
                 <a:solidFill>
-                  <a:srgbClr val="6B6860"/>
+                  <a:srgbClr val="4A6B8A"/>
                 </a:solidFill>
                 <a:latin typeface="Calibri" pitchFamily="34" charset="0"/>
                 <a:ea typeface="Calibri" pitchFamily="34" charset="-122"/>
@@ -15771,7 +15771,7 @@
             <a:r>
               <a:rPr lang="en-US" sz="1000" dirty="0">
                 <a:solidFill>
-                  <a:srgbClr val="6B6860"/>
+                  <a:srgbClr val="4A6B8A"/>
                 </a:solidFill>
                 <a:latin typeface="Calibri" pitchFamily="34" charset="0"/>
                 <a:ea typeface="Calibri" pitchFamily="34" charset="-122"/>
@@ -15797,7 +15797,7 @@
     <p:bg>
       <p:bgPr>
         <a:solidFill>
-          <a:srgbClr val="F7F5F0"/>
+          <a:srgbClr val="F5F8FC"/>
         </a:solidFill>
       </p:bgPr>
     </p:bg>
@@ -15842,7 +15842,7 @@
             <a:r>
               <a:rPr lang="en-US" sz="1200" b="1" spc="150" kern="0" dirty="0">
                 <a:solidFill>
-                  <a:srgbClr val="A3690C"/>
+                  <a:srgbClr val="964F2E"/>
                 </a:solidFill>
                 <a:latin typeface="Calibri" pitchFamily="34" charset="0"/>
                 <a:ea typeface="Calibri" pitchFamily="34" charset="-122"/>
@@ -15881,7 +15881,7 @@
             <a:r>
               <a:rPr lang="en-US" sz="3000" b="1" dirty="0">
                 <a:solidFill>
-                  <a:srgbClr val="201D18"/>
+                  <a:srgbClr val="002D72"/>
                 </a:solidFill>
                 <a:latin typeface="Georgia" pitchFamily="34" charset="0"/>
                 <a:ea typeface="Georgia" pitchFamily="34" charset="-122"/>
@@ -15946,7 +15946,7 @@
             <a:r>
               <a:rPr lang="en-US" sz="1400" dirty="0">
                 <a:solidFill>
-                  <a:srgbClr val="201D18"/>
+                  <a:srgbClr val="002D72"/>
                 </a:solidFill>
                 <a:latin typeface="Calibri" pitchFamily="34" charset="0"/>
                 <a:ea typeface="Calibri" pitchFamily="34" charset="-122"/>
@@ -15963,7 +15963,7 @@
             <a:r>
               <a:rPr lang="en-US" sz="1400" b="1" dirty="0">
                 <a:solidFill>
-                  <a:srgbClr val="A3690C"/>
+                  <a:srgbClr val="964F2E"/>
                 </a:solidFill>
                 <a:latin typeface="Calibri" pitchFamily="34" charset="0"/>
                 <a:ea typeface="Calibri" pitchFamily="34" charset="-122"/>
@@ -15980,7 +15980,7 @@
             <a:r>
               <a:rPr lang="en-US" sz="1400" dirty="0">
                 <a:solidFill>
-                  <a:srgbClr val="201D18"/>
+                  <a:srgbClr val="002D72"/>
                 </a:solidFill>
                 <a:latin typeface="Calibri" pitchFamily="34" charset="0"/>
                 <a:ea typeface="Calibri" pitchFamily="34" charset="-122"/>
@@ -16022,7 +16022,7 @@
             <a:r>
               <a:rPr lang="en-US" sz="1200" dirty="0">
                 <a:solidFill>
-                  <a:srgbClr val="6B6860"/>
+                  <a:srgbClr val="4A6B8A"/>
                 </a:solidFill>
                 <a:latin typeface="Calibri" pitchFamily="34" charset="0"/>
                 <a:ea typeface="Calibri" pitchFamily="34" charset="-122"/>
@@ -16063,7 +16063,7 @@
             <a:r>
               <a:rPr lang="en-US" sz="1200" b="1" u="sng" dirty="0">
                 <a:solidFill>
-                  <a:srgbClr val="0F6E67"/>
+                  <a:srgbClr val="002D72"/>
                 </a:solidFill>
                 <a:latin typeface="Calibri" pitchFamily="34" charset="0"/>
                 <a:ea typeface="Calibri" pitchFamily="34" charset="-122"/>
@@ -16109,7 +16109,7 @@
             <a:r>
               <a:rPr lang="en-US" sz="1000" dirty="0">
                 <a:solidFill>
-                  <a:srgbClr val="6B6860"/>
+                  <a:srgbClr val="4A6B8A"/>
                 </a:solidFill>
                 <a:latin typeface="Calibri" pitchFamily="34" charset="0"/>
                 <a:ea typeface="Calibri" pitchFamily="34" charset="-122"/>
@@ -16135,7 +16135,7 @@
     <p:bg>
       <p:bgPr>
         <a:solidFill>
-          <a:srgbClr val="12161A"/>
+          <a:srgbClr val="68ACE5"/>
         </a:solidFill>
       </p:bgPr>
     </p:bg>
@@ -16180,7 +16180,7 @@
             <a:r>
               <a:rPr lang="en-US" sz="1400" b="1" spc="200" kern="0" dirty="0">
                 <a:solidFill>
-                  <a:srgbClr val="A3690C"/>
+                  <a:srgbClr val="002D72"/>
                 </a:solidFill>
                 <a:latin typeface="Calibri" pitchFamily="34" charset="0"/>
                 <a:ea typeface="Calibri" pitchFamily="34" charset="-122"/>
@@ -16219,7 +16219,7 @@
             <a:r>
               <a:rPr lang="en-US" sz="11000" b="1" dirty="0">
                 <a:solidFill>
-                  <a:srgbClr val="23282E"/>
+                  <a:srgbClr val="8FC4EE"/>
                 </a:solidFill>
                 <a:latin typeface="Georgia" pitchFamily="34" charset="0"/>
                 <a:ea typeface="Georgia" pitchFamily="34" charset="-122"/>
@@ -16261,7 +16261,7 @@
             <a:r>
               <a:rPr lang="en-US" sz="3800" b="1" dirty="0">
                 <a:solidFill>
-                  <a:srgbClr val="E8E4DB"/>
+                  <a:srgbClr val="002D72"/>
                 </a:solidFill>
                 <a:latin typeface="Georgia" pitchFamily="34" charset="0"/>
                 <a:ea typeface="Georgia" pitchFamily="34" charset="-122"/>
@@ -16303,7 +16303,7 @@
             <a:r>
               <a:rPr lang="en-US" sz="1500" i="1" dirty="0">
                 <a:solidFill>
-                  <a:srgbClr val="9B968C"/>
+                  <a:srgbClr val="002D72"/>
                 </a:solidFill>
                 <a:latin typeface="Calibri" pitchFamily="34" charset="0"/>
                 <a:ea typeface="Calibri" pitchFamily="34" charset="-122"/>
@@ -16329,7 +16329,7 @@
     <p:bg>
       <p:bgPr>
         <a:solidFill>
-          <a:srgbClr val="F7F5F0"/>
+          <a:srgbClr val="F5F8FC"/>
         </a:solidFill>
       </p:bgPr>
     </p:bg>
@@ -16374,7 +16374,7 @@
             <a:r>
               <a:rPr lang="en-US" sz="1200" b="1" spc="150" kern="0" dirty="0">
                 <a:solidFill>
-                  <a:srgbClr val="A3690C"/>
+                  <a:srgbClr val="964F2E"/>
                 </a:solidFill>
                 <a:latin typeface="Calibri" pitchFamily="34" charset="0"/>
                 <a:ea typeface="Calibri" pitchFamily="34" charset="-122"/>
@@ -16413,7 +16413,7 @@
             <a:r>
               <a:rPr lang="en-US" sz="3000" b="1" dirty="0">
                 <a:solidFill>
-                  <a:srgbClr val="201D18"/>
+                  <a:srgbClr val="002D72"/>
                 </a:solidFill>
                 <a:latin typeface="Georgia" pitchFamily="34" charset="0"/>
                 <a:ea typeface="Georgia" pitchFamily="34" charset="-122"/>
@@ -16444,7 +16444,7 @@
           </a:solidFill>
           <a:ln w="12700">
             <a:solidFill>
-              <a:srgbClr val="E2DDD2"/>
+              <a:srgbClr val="D6E4F2"/>
             </a:solidFill>
             <a:prstDash val="solid"/>
           </a:ln>
@@ -16477,7 +16477,7 @@
             <a:r>
               <a:rPr lang="en-US" sz="2600" b="1" dirty="0">
                 <a:solidFill>
-                  <a:srgbClr val="0F6E67"/>
+                  <a:srgbClr val="002D72"/>
                 </a:solidFill>
                 <a:latin typeface="Georgia" pitchFamily="34" charset="0"/>
                 <a:ea typeface="Georgia" pitchFamily="34" charset="-122"/>
@@ -16516,7 +16516,7 @@
             <a:r>
               <a:rPr lang="en-US" sz="1200" b="1" dirty="0">
                 <a:solidFill>
-                  <a:srgbClr val="A3690C"/>
+                  <a:srgbClr val="964F2E"/>
                 </a:solidFill>
                 <a:latin typeface="Calibri" pitchFamily="34" charset="0"/>
                 <a:ea typeface="Calibri" pitchFamily="34" charset="-122"/>
@@ -16558,7 +16558,7 @@
             <a:r>
               <a:rPr lang="en-US" sz="1400" dirty="0">
                 <a:solidFill>
-                  <a:srgbClr val="201D18"/>
+                  <a:srgbClr val="002D72"/>
                 </a:solidFill>
                 <a:latin typeface="Calibri" pitchFamily="34" charset="0"/>
                 <a:ea typeface="Calibri" pitchFamily="34" charset="-122"/>
@@ -16589,7 +16589,7 @@
           </a:solidFill>
           <a:ln w="12700">
             <a:solidFill>
-              <a:srgbClr val="E2DDD2"/>
+              <a:srgbClr val="D6E4F2"/>
             </a:solidFill>
             <a:prstDash val="solid"/>
           </a:ln>
@@ -16622,7 +16622,7 @@
             <a:r>
               <a:rPr lang="en-US" sz="2600" b="1" dirty="0">
                 <a:solidFill>
-                  <a:srgbClr val="0F6E67"/>
+                  <a:srgbClr val="002D72"/>
                 </a:solidFill>
                 <a:latin typeface="Georgia" pitchFamily="34" charset="0"/>
                 <a:ea typeface="Georgia" pitchFamily="34" charset="-122"/>
@@ -16661,7 +16661,7 @@
             <a:r>
               <a:rPr lang="en-US" sz="1200" b="1" dirty="0">
                 <a:solidFill>
-                  <a:srgbClr val="A3690C"/>
+                  <a:srgbClr val="964F2E"/>
                 </a:solidFill>
                 <a:latin typeface="Calibri" pitchFamily="34" charset="0"/>
                 <a:ea typeface="Calibri" pitchFamily="34" charset="-122"/>
@@ -16703,7 +16703,7 @@
             <a:r>
               <a:rPr lang="en-US" sz="1400" dirty="0">
                 <a:solidFill>
-                  <a:srgbClr val="201D18"/>
+                  <a:srgbClr val="002D72"/>
                 </a:solidFill>
                 <a:latin typeface="Calibri" pitchFamily="34" charset="0"/>
                 <a:ea typeface="Calibri" pitchFamily="34" charset="-122"/>
@@ -16742,7 +16742,7 @@
             <a:r>
               <a:rPr lang="en-US" sz="1000" dirty="0">
                 <a:solidFill>
-                  <a:srgbClr val="6B6860"/>
+                  <a:srgbClr val="4A6B8A"/>
                 </a:solidFill>
                 <a:latin typeface="Calibri" pitchFamily="34" charset="0"/>
                 <a:ea typeface="Calibri" pitchFamily="34" charset="-122"/>
@@ -16756,7 +16756,7 @@
             <a:r>
               <a:rPr lang="en-US" sz="1000" u="sng" dirty="0">
                 <a:solidFill>
-                  <a:srgbClr val="6B6860"/>
+                  <a:srgbClr val="4A6B8A"/>
                 </a:solidFill>
                 <a:latin typeface="Calibri" pitchFamily="34" charset="0"/>
                 <a:ea typeface="Calibri" pitchFamily="34" charset="-122"/>
@@ -16777,7 +16777,7 @@
             <a:r>
               <a:rPr lang="en-US" sz="1000" dirty="0">
                 <a:solidFill>
-                  <a:srgbClr val="6B6860"/>
+                  <a:srgbClr val="4A6B8A"/>
                 </a:solidFill>
                 <a:latin typeface="Calibri" pitchFamily="34" charset="0"/>
                 <a:ea typeface="Calibri" pitchFamily="34" charset="-122"/>
@@ -16791,7 +16791,7 @@
             <a:r>
               <a:rPr lang="en-US" sz="1000" u="sng" dirty="0">
                 <a:solidFill>
-                  <a:srgbClr val="6B6860"/>
+                  <a:srgbClr val="4A6B8A"/>
                 </a:solidFill>
                 <a:latin typeface="Calibri" pitchFamily="34" charset="0"/>
                 <a:ea typeface="Calibri" pitchFamily="34" charset="-122"/>
@@ -16837,7 +16837,7 @@
             <a:r>
               <a:rPr lang="en-US" sz="1000" dirty="0">
                 <a:solidFill>
-                  <a:srgbClr val="6B6860"/>
+                  <a:srgbClr val="4A6B8A"/>
                 </a:solidFill>
                 <a:latin typeface="Calibri" pitchFamily="34" charset="0"/>
                 <a:ea typeface="Calibri" pitchFamily="34" charset="-122"/>
@@ -16863,7 +16863,7 @@
     <p:bg>
       <p:bgPr>
         <a:solidFill>
-          <a:srgbClr val="F7F5F0"/>
+          <a:srgbClr val="F5F8FC"/>
         </a:solidFill>
       </p:bgPr>
     </p:bg>
@@ -16908,7 +16908,7 @@
             <a:r>
               <a:rPr lang="en-US" sz="1200" b="1" spc="150" kern="0" dirty="0">
                 <a:solidFill>
-                  <a:srgbClr val="A3690C"/>
+                  <a:srgbClr val="964F2E"/>
                 </a:solidFill>
                 <a:latin typeface="Calibri" pitchFamily="34" charset="0"/>
                 <a:ea typeface="Calibri" pitchFamily="34" charset="-122"/>
@@ -16947,7 +16947,7 @@
             <a:r>
               <a:rPr lang="en-US" sz="3000" b="1" dirty="0">
                 <a:solidFill>
-                  <a:srgbClr val="201D18"/>
+                  <a:srgbClr val="002D72"/>
                 </a:solidFill>
                 <a:latin typeface="Georgia" pitchFamily="34" charset="0"/>
                 <a:ea typeface="Georgia" pitchFamily="34" charset="-122"/>
@@ -16978,7 +16978,7 @@
           </a:solidFill>
           <a:ln w="12700">
             <a:solidFill>
-              <a:srgbClr val="E2DDD2"/>
+              <a:srgbClr val="D6E4F2"/>
             </a:solidFill>
             <a:prstDash val="solid"/>
           </a:ln>
@@ -17011,7 +17011,7 @@
             <a:r>
               <a:rPr lang="en-US" sz="4400" b="1" dirty="0">
                 <a:solidFill>
-                  <a:srgbClr val="A3690C"/>
+                  <a:srgbClr val="964F2E"/>
                 </a:solidFill>
                 <a:latin typeface="Georgia" pitchFamily="34" charset="0"/>
                 <a:ea typeface="Georgia" pitchFamily="34" charset="-122"/>
@@ -17053,7 +17053,7 @@
             <a:r>
               <a:rPr lang="en-US" sz="1150" dirty="0">
                 <a:solidFill>
-                  <a:srgbClr val="6B6860"/>
+                  <a:srgbClr val="4A6B8A"/>
                 </a:solidFill>
                 <a:latin typeface="Calibri" pitchFamily="34" charset="0"/>
                 <a:ea typeface="Calibri" pitchFamily="34" charset="-122"/>
@@ -17073,7 +17073,7 @@
             <a:r>
               <a:rPr lang="en-US" sz="1150" dirty="0">
                 <a:solidFill>
-                  <a:srgbClr val="6B6860"/>
+                  <a:srgbClr val="4A6B8A"/>
                 </a:solidFill>
                 <a:latin typeface="Calibri" pitchFamily="34" charset="0"/>
                 <a:ea typeface="Calibri" pitchFamily="34" charset="-122"/>
@@ -17104,7 +17104,7 @@
           </a:solidFill>
           <a:ln w="12700">
             <a:solidFill>
-              <a:srgbClr val="E2DDD2"/>
+              <a:srgbClr val="D6E4F2"/>
             </a:solidFill>
             <a:prstDash val="solid"/>
           </a:ln>
@@ -17137,7 +17137,7 @@
             <a:r>
               <a:rPr lang="en-US" sz="4400" b="1" dirty="0">
                 <a:solidFill>
-                  <a:srgbClr val="A3690C"/>
+                  <a:srgbClr val="964F2E"/>
                 </a:solidFill>
                 <a:latin typeface="Georgia" pitchFamily="34" charset="0"/>
                 <a:ea typeface="Georgia" pitchFamily="34" charset="-122"/>
@@ -17179,7 +17179,7 @@
             <a:r>
               <a:rPr lang="en-US" sz="1150" dirty="0">
                 <a:solidFill>
-                  <a:srgbClr val="6B6860"/>
+                  <a:srgbClr val="4A6B8A"/>
                 </a:solidFill>
                 <a:latin typeface="Calibri" pitchFamily="34" charset="0"/>
                 <a:ea typeface="Calibri" pitchFamily="34" charset="-122"/>
@@ -17199,7 +17199,7 @@
             <a:r>
               <a:rPr lang="en-US" sz="1150" dirty="0">
                 <a:solidFill>
-                  <a:srgbClr val="6B6860"/>
+                  <a:srgbClr val="4A6B8A"/>
                 </a:solidFill>
                 <a:latin typeface="Calibri" pitchFamily="34" charset="0"/>
                 <a:ea typeface="Calibri" pitchFamily="34" charset="-122"/>
@@ -17219,7 +17219,7 @@
             <a:r>
               <a:rPr lang="en-US" sz="1150" dirty="0">
                 <a:solidFill>
-                  <a:srgbClr val="6B6860"/>
+                  <a:srgbClr val="4A6B8A"/>
                 </a:solidFill>
                 <a:latin typeface="Calibri" pitchFamily="34" charset="0"/>
                 <a:ea typeface="Calibri" pitchFamily="34" charset="-122"/>
@@ -17250,7 +17250,7 @@
           </a:solidFill>
           <a:ln w="12700">
             <a:solidFill>
-              <a:srgbClr val="E2DDD2"/>
+              <a:srgbClr val="D6E4F2"/>
             </a:solidFill>
             <a:prstDash val="solid"/>
           </a:ln>
@@ -17283,7 +17283,7 @@
             <a:r>
               <a:rPr lang="en-US" sz="2400" b="1" dirty="0">
                 <a:solidFill>
-                  <a:srgbClr val="A3690C"/>
+                  <a:srgbClr val="964F2E"/>
                 </a:solidFill>
                 <a:latin typeface="Georgia" pitchFamily="34" charset="0"/>
                 <a:ea typeface="Georgia" pitchFamily="34" charset="-122"/>
@@ -17325,7 +17325,7 @@
             <a:r>
               <a:rPr lang="en-US" sz="1150" dirty="0">
                 <a:solidFill>
-                  <a:srgbClr val="6B6860"/>
+                  <a:srgbClr val="4A6B8A"/>
                 </a:solidFill>
                 <a:latin typeface="Calibri" pitchFamily="34" charset="0"/>
                 <a:ea typeface="Calibri" pitchFamily="34" charset="-122"/>
@@ -17345,7 +17345,7 @@
             <a:r>
               <a:rPr lang="en-US" sz="1150" dirty="0">
                 <a:solidFill>
-                  <a:srgbClr val="6B6860"/>
+                  <a:srgbClr val="4A6B8A"/>
                 </a:solidFill>
                 <a:latin typeface="Calibri" pitchFamily="34" charset="0"/>
                 <a:ea typeface="Calibri" pitchFamily="34" charset="-122"/>
@@ -17387,7 +17387,7 @@
             <a:r>
               <a:rPr lang="en-US" sz="1500" i="1" dirty="0">
                 <a:solidFill>
-                  <a:srgbClr val="201D18"/>
+                  <a:srgbClr val="002D72"/>
                 </a:solidFill>
                 <a:latin typeface="Calibri" pitchFamily="34" charset="0"/>
                 <a:ea typeface="Calibri" pitchFamily="34" charset="-122"/>
@@ -17426,7 +17426,7 @@
             <a:r>
               <a:rPr lang="en-US" sz="1000" dirty="0">
                 <a:solidFill>
-                  <a:srgbClr val="6B6860"/>
+                  <a:srgbClr val="4A6B8A"/>
                 </a:solidFill>
                 <a:latin typeface="Calibri" pitchFamily="34" charset="0"/>
                 <a:ea typeface="Calibri" pitchFamily="34" charset="-122"/>
@@ -17440,7 +17440,7 @@
             <a:r>
               <a:rPr lang="en-US" sz="1000" u="sng" dirty="0">
                 <a:solidFill>
-                  <a:srgbClr val="6B6860"/>
+                  <a:srgbClr val="4A6B8A"/>
                 </a:solidFill>
                 <a:latin typeface="Calibri" pitchFamily="34" charset="0"/>
                 <a:ea typeface="Calibri" pitchFamily="34" charset="-122"/>
@@ -17486,7 +17486,7 @@
             <a:r>
               <a:rPr lang="en-US" sz="1000" dirty="0">
                 <a:solidFill>
-                  <a:srgbClr val="6B6860"/>
+                  <a:srgbClr val="4A6B8A"/>
                 </a:solidFill>
                 <a:latin typeface="Calibri" pitchFamily="34" charset="0"/>
                 <a:ea typeface="Calibri" pitchFamily="34" charset="-122"/>
@@ -17512,7 +17512,7 @@
     <p:bg>
       <p:bgPr>
         <a:solidFill>
-          <a:srgbClr val="F7F5F0"/>
+          <a:srgbClr val="F5F8FC"/>
         </a:solidFill>
       </p:bgPr>
     </p:bg>
@@ -17557,7 +17557,7 @@
             <a:r>
               <a:rPr lang="en-US" sz="1200" b="1" spc="150" kern="0" dirty="0">
                 <a:solidFill>
-                  <a:srgbClr val="A3690C"/>
+                  <a:srgbClr val="964F2E"/>
                 </a:solidFill>
                 <a:latin typeface="Calibri" pitchFamily="34" charset="0"/>
                 <a:ea typeface="Calibri" pitchFamily="34" charset="-122"/>
@@ -17596,7 +17596,7 @@
             <a:r>
               <a:rPr lang="en-US" sz="3000" b="1" dirty="0">
                 <a:solidFill>
-                  <a:srgbClr val="201D18"/>
+                  <a:srgbClr val="002D72"/>
                 </a:solidFill>
                 <a:latin typeface="Georgia" pitchFamily="34" charset="0"/>
                 <a:ea typeface="Georgia" pitchFamily="34" charset="-122"/>
@@ -17642,7 +17642,7 @@
             <a:r>
               <a:rPr lang="en-US" sz="1600" dirty="0">
                 <a:solidFill>
-                  <a:srgbClr val="201D18"/>
+                  <a:srgbClr val="002D72"/>
                 </a:solidFill>
                 <a:latin typeface="Calibri" pitchFamily="34" charset="0"/>
                 <a:ea typeface="Calibri" pitchFamily="34" charset="-122"/>
@@ -17666,7 +17666,7 @@
             <a:r>
               <a:rPr lang="en-US" sz="1600" dirty="0">
                 <a:solidFill>
-                  <a:srgbClr val="201D18"/>
+                  <a:srgbClr val="002D72"/>
                 </a:solidFill>
                 <a:latin typeface="Calibri" pitchFamily="34" charset="0"/>
                 <a:ea typeface="Calibri" pitchFamily="34" charset="-122"/>
@@ -17690,7 +17690,7 @@
             <a:r>
               <a:rPr lang="en-US" sz="1600" dirty="0">
                 <a:solidFill>
-                  <a:srgbClr val="201D18"/>
+                  <a:srgbClr val="002D72"/>
                 </a:solidFill>
                 <a:latin typeface="Calibri" pitchFamily="34" charset="0"/>
                 <a:ea typeface="Calibri" pitchFamily="34" charset="-122"/>
@@ -17714,7 +17714,7 @@
             <a:r>
               <a:rPr lang="en-US" sz="1600" dirty="0">
                 <a:solidFill>
-                  <a:srgbClr val="201D18"/>
+                  <a:srgbClr val="002D72"/>
                 </a:solidFill>
                 <a:latin typeface="Calibri" pitchFamily="34" charset="0"/>
                 <a:ea typeface="Calibri" pitchFamily="34" charset="-122"/>
@@ -17741,11 +17741,11 @@
             <a:avLst/>
           </a:prstGeom>
           <a:solidFill>
-            <a:srgbClr val="ECDCBD"/>
+            <a:srgbClr val="F6E7C9"/>
           </a:solidFill>
           <a:ln w="12700">
             <a:solidFill>
-              <a:srgbClr val="E2DDD2"/>
+              <a:srgbClr val="D6E4F2"/>
             </a:solidFill>
             <a:prstDash val="solid"/>
           </a:ln>
@@ -17781,7 +17781,7 @@
             <a:r>
               <a:rPr lang="en-US" sz="1700" b="1" i="1" dirty="0">
                 <a:solidFill>
-                  <a:srgbClr val="201D18"/>
+                  <a:srgbClr val="002D72"/>
                 </a:solidFill>
                 <a:latin typeface="Georgia" pitchFamily="34" charset="0"/>
                 <a:ea typeface="Georgia" pitchFamily="34" charset="-122"/>
@@ -17820,7 +17820,7 @@
             <a:r>
               <a:rPr lang="en-US" sz="1200" b="1" dirty="0">
                 <a:solidFill>
-                  <a:srgbClr val="A3690C"/>
+                  <a:srgbClr val="964F2E"/>
                 </a:solidFill>
                 <a:latin typeface="Calibri" pitchFamily="34" charset="0"/>
                 <a:ea typeface="Calibri" pitchFamily="34" charset="-122"/>
@@ -17859,7 +17859,7 @@
             <a:r>
               <a:rPr lang="en-US" sz="1000" dirty="0">
                 <a:solidFill>
-                  <a:srgbClr val="6B6860"/>
+                  <a:srgbClr val="4A6B8A"/>
                 </a:solidFill>
                 <a:latin typeface="Calibri" pitchFamily="34" charset="0"/>
                 <a:ea typeface="Calibri" pitchFamily="34" charset="-122"/>
@@ -17873,7 +17873,7 @@
             <a:r>
               <a:rPr lang="en-US" sz="1000" u="sng" dirty="0">
                 <a:solidFill>
-                  <a:srgbClr val="6B6860"/>
+                  <a:srgbClr val="4A6B8A"/>
                 </a:solidFill>
                 <a:latin typeface="Calibri" pitchFamily="34" charset="0"/>
                 <a:ea typeface="Calibri" pitchFamily="34" charset="-122"/>
@@ -17894,7 +17894,7 @@
             <a:r>
               <a:rPr lang="en-US" sz="1000" dirty="0">
                 <a:solidFill>
-                  <a:srgbClr val="6B6860"/>
+                  <a:srgbClr val="4A6B8A"/>
                 </a:solidFill>
                 <a:latin typeface="Calibri" pitchFamily="34" charset="0"/>
                 <a:ea typeface="Calibri" pitchFamily="34" charset="-122"/>
@@ -17908,7 +17908,7 @@
             <a:r>
               <a:rPr lang="en-US" sz="1000" u="sng" dirty="0">
                 <a:solidFill>
-                  <a:srgbClr val="6B6860"/>
+                  <a:srgbClr val="4A6B8A"/>
                 </a:solidFill>
                 <a:latin typeface="Calibri" pitchFamily="34" charset="0"/>
                 <a:ea typeface="Calibri" pitchFamily="34" charset="-122"/>
@@ -17954,7 +17954,7 @@
             <a:r>
               <a:rPr lang="en-US" sz="1000" dirty="0">
                 <a:solidFill>
-                  <a:srgbClr val="6B6860"/>
+                  <a:srgbClr val="4A6B8A"/>
                 </a:solidFill>
                 <a:latin typeface="Calibri" pitchFamily="34" charset="0"/>
                 <a:ea typeface="Calibri" pitchFamily="34" charset="-122"/>

</xml_diff>